<commit_message>
experiments: validate bounded LLM authority on disjoint routes
</commit_message>
<xml_diff>
--- a/CARE2.0_Nature_evidence_update_2026-08-24.pptx
+++ b/CARE2.0_Nature_evidence_update_2026-08-24.pptx
@@ -2,27 +2,27 @@
 <file path=ppt/presentation.xml><?xml version="1.0" encoding="utf-8"?>
 <p:presentation xmlns:p="http://schemas.openxmlformats.org/presentationml/2006/main">
   <p:sldMasterIdLst>
-    <p:sldMasterId xmlns:r="http://schemas.openxmlformats.org/officeDocument/2006/relationships" id="2147483648" r:id="R2d93c2670b2848ca"/>
+    <p:sldMasterId xmlns:r="http://schemas.openxmlformats.org/officeDocument/2006/relationships" id="2147483648" r:id="Rcae0aef4663c4396"/>
   </p:sldMasterIdLst>
   <p:notesMasterIdLst>
-    <p:notesMasterId xmlns:r="http://schemas.openxmlformats.org/officeDocument/2006/relationships" r:id="R3ee392c8fdf243ca"/>
+    <p:notesMasterId xmlns:r="http://schemas.openxmlformats.org/officeDocument/2006/relationships" r:id="R85449462af104264"/>
   </p:notesMasterIdLst>
   <p:sldIdLst>
-    <p:sldId xmlns:r="http://schemas.openxmlformats.org/officeDocument/2006/relationships" id="256" r:id="Rc42963c004454a03"/>
-    <p:sldId xmlns:r="http://schemas.openxmlformats.org/officeDocument/2006/relationships" id="257" r:id="R694f2651dcfd4aeb"/>
-    <p:sldId xmlns:r="http://schemas.openxmlformats.org/officeDocument/2006/relationships" id="258" r:id="R00f1edb94faa46ad"/>
-    <p:sldId xmlns:r="http://schemas.openxmlformats.org/officeDocument/2006/relationships" id="259" r:id="R47060852d5d7414b"/>
-    <p:sldId xmlns:r="http://schemas.openxmlformats.org/officeDocument/2006/relationships" id="260" r:id="Rcfb9e31ac3aa4727"/>
-    <p:sldId xmlns:r="http://schemas.openxmlformats.org/officeDocument/2006/relationships" id="261" r:id="Rfe30eae4ac744234"/>
-    <p:sldId xmlns:r="http://schemas.openxmlformats.org/officeDocument/2006/relationships" id="262" r:id="R88bcc2ef117c43a0"/>
-    <p:sldId xmlns:r="http://schemas.openxmlformats.org/officeDocument/2006/relationships" id="263" r:id="Rea97f9b3b6104008"/>
-    <p:sldId xmlns:r="http://schemas.openxmlformats.org/officeDocument/2006/relationships" id="264" r:id="Rcd8b6ca0bd5e4832"/>
-    <p:sldId xmlns:r="http://schemas.openxmlformats.org/officeDocument/2006/relationships" id="265" r:id="Rd18306167149470b"/>
-    <p:sldId xmlns:r="http://schemas.openxmlformats.org/officeDocument/2006/relationships" id="266" r:id="Ra444a0e76a7e4a2d"/>
-    <p:sldId xmlns:r="http://schemas.openxmlformats.org/officeDocument/2006/relationships" id="267" r:id="R3039a8cf326441e5"/>
-    <p:sldId xmlns:r="http://schemas.openxmlformats.org/officeDocument/2006/relationships" id="268" r:id="R1580f7878d004687"/>
-    <p:sldId xmlns:r="http://schemas.openxmlformats.org/officeDocument/2006/relationships" id="269" r:id="R5f83d4db7b3640f0"/>
-    <p:sldId xmlns:r="http://schemas.openxmlformats.org/officeDocument/2006/relationships" id="270" r:id="R5143af8e43854349"/>
+    <p:sldId xmlns:r="http://schemas.openxmlformats.org/officeDocument/2006/relationships" id="256" r:id="R3d088e0cfd544c83"/>
+    <p:sldId xmlns:r="http://schemas.openxmlformats.org/officeDocument/2006/relationships" id="257" r:id="R8aac0b5cda464252"/>
+    <p:sldId xmlns:r="http://schemas.openxmlformats.org/officeDocument/2006/relationships" id="258" r:id="Ra60f19e405c740fd"/>
+    <p:sldId xmlns:r="http://schemas.openxmlformats.org/officeDocument/2006/relationships" id="259" r:id="Ra142c86427944056"/>
+    <p:sldId xmlns:r="http://schemas.openxmlformats.org/officeDocument/2006/relationships" id="260" r:id="Rb4e26669f8394dc2"/>
+    <p:sldId xmlns:r="http://schemas.openxmlformats.org/officeDocument/2006/relationships" id="261" r:id="R22093593588f4c40"/>
+    <p:sldId xmlns:r="http://schemas.openxmlformats.org/officeDocument/2006/relationships" id="262" r:id="R7e8cab31458a4390"/>
+    <p:sldId xmlns:r="http://schemas.openxmlformats.org/officeDocument/2006/relationships" id="263" r:id="Rae3789ef306c41b2"/>
+    <p:sldId xmlns:r="http://schemas.openxmlformats.org/officeDocument/2006/relationships" id="264" r:id="R2866aafcedfc40c0"/>
+    <p:sldId xmlns:r="http://schemas.openxmlformats.org/officeDocument/2006/relationships" id="265" r:id="Rdf72775c286043a0"/>
+    <p:sldId xmlns:r="http://schemas.openxmlformats.org/officeDocument/2006/relationships" id="266" r:id="R49843bea4b0747a6"/>
+    <p:sldId xmlns:r="http://schemas.openxmlformats.org/officeDocument/2006/relationships" id="267" r:id="R8e6a1c3b99484b09"/>
+    <p:sldId xmlns:r="http://schemas.openxmlformats.org/officeDocument/2006/relationships" id="268" r:id="R2a759f1cbcae4eb4"/>
+    <p:sldId xmlns:r="http://schemas.openxmlformats.org/officeDocument/2006/relationships" id="269" r:id="R59cdf3db573049bc"/>
+    <p:sldId xmlns:r="http://schemas.openxmlformats.org/officeDocument/2006/relationships" id="270" r:id="R155f3b6be5214d3b"/>
   </p:sldIdLst>
   <p:sldSz cx="12192000" cy="6858000"/>
   <p:notesSz cx="6858000" cy="9144000"/>
@@ -941,7 +941,7 @@
           </a:p>
           <a:p xmlns:a="http://schemas.openxmlformats.org/drawingml/2006/main">
             <a:r>
-              <a:t>冻结 11 路线中，原始在线 LLM 相对同开局 target-only GP-UCB 的平均 best-so-far AUC 增益为 +1.753。将全局阈值 5 固定到第三轮后，回放均值为 +2.135，route-bootstrap 95% 区间为 [+0.515,+4.001]，负向路线从 3 条降到 2 条。完整 17 路线盘点仍只有 +0.762，区间跨 0；面对每条路线事后最强 baseline，多数路线仍然落后。因此当前最准确定位是“可审计、可执行、能控制负迁移的 LLM 迁移控制器”，而不是“已经普遍优于现有优化器”。</a:t>
+              <a:t>冻结 11 路线中，原始在线 LLM 相对同开局 target-only GP-UCB 的平均 best-so-far AUC 增益为 +1.753；完整 17 路线盘点降到 +0.762，区间跨 0。更严格的六条分离路线没有参与策略选择：完整 LLM 均值为 -1.056，第三轮阈值 5 Gate 为 -1.968，说明原 Gate 在开发路线上的改善不能外推。用 11 条训练路线比较 115 个控制器后，训练规则选出“LLM 在线决策一轮，随后交回 GP”；它在六条分离路线中的均值为 +0.612，2 胜、3 平、1 负，但区间仍跨 0。因此当前最准确定位是“找到了一个更合理、需要前瞻验证的 LLM 介入边界”。</a:t>
             </a:r>
           </a:p>
           <a:p xmlns:a="http://schemas.openxmlformats.org/drawingml/2006/main">
@@ -966,7 +966,7 @@
           </a:p>
           <a:p xmlns:a="http://schemas.openxmlformats.org/drawingml/2006/main">
             <a:r>
-              <a:t>- experiments/care_replay/results/2026-08-24-online-llm-fixed-threshold5-gate-replay-v1/aggregate.json</a:t>
+              <a:t>- experiments/care_replay/results/2026-08-24-online-llm-route-split-gate-selection-v1/selected_policy.json</a:t>
             </a:r>
           </a:p>
         </p:txBody>
@@ -1041,7 +1041,7 @@
           </a:p>
           <a:p xmlns:a="http://schemas.openxmlformats.org/drawingml/2006/main">
             <a:r>
-              <a:t>运行时 Gate 已接入代码，并且未来重复确认协议已经在新调用前冻结。</a:t>
+              <a:t>单轮 LLM 的运行时交接已经接入代码，并且重复确认协议已经在新调用前冻结。</a:t>
             </a:r>
           </a:p>
           <a:p xmlns:a="http://schemas.openxmlformats.org/drawingml/2006/main">
@@ -1056,7 +1056,7 @@
           </a:p>
           <a:p xmlns:a="http://schemas.openxmlformats.org/drawingml/2006/main">
             <a:r>
-              <a:t>协议包含 11 条 source-target 路线，每条 30 次，共 330 条未来随机轨迹。每条轨迹使用相同的初始观测、10 轮预算、Opus 4.8 proposer + critic 和强 baseline。Gate 固定在第三次 LLM 引导的 target reveal 后评估：前三轮明确预测的平均绝对误差超过 5，或 LLM 证伪并主动停止迁移，后面就不再调用 LLM，而是让 target-only GP-UCB 从已经积累的全部观测继续。协议禁止按中间结果删路线、改阈值或提前停止。截至 2026-08-24，协议已经冻结，但 330 条新轨迹尚未完成，所以不能把本页写成前瞻确认结果。</a:t>
+              <a:t>协议包含 6 条没有参与控制器选择的 source-target 路线，每条 30 次，共 180 条新随机轨迹。每条轨迹使用相同初始观测、10 轮预算、Opus 4.8 proposer + critic 和同开局 target-only GP。LLM 只控制第一次在线 reveal；从第二轮开始不再调用 LLM，由 target-only GP-UCB 从初始观测和第一轮结果继续。协议禁止根据中间结果删路线、改控制器或提前停止。必须完成全部 180 条轨迹，才计算主要层级 bootstrap 结论。路线名称和每条路线的一条旧轨迹此前已知，因此即使完成也属于内部重复确认，不是外部新任务或 wet-lab 证明。</a:t>
             </a:r>
           </a:p>
           <a:p xmlns:a="http://schemas.openxmlformats.org/drawingml/2006/main">
@@ -1071,7 +1071,7 @@
           </a:p>
           <a:p xmlns:a="http://schemas.openxmlformats.org/drawingml/2006/main">
             <a:r>
-              <a:t>- experiments/care_replay/configs/online_llm_gated_repeated_confirmation_v1.json</a:t>
+              <a:t>- experiments/care_replay/configs/online_llm_bounded_authority_route_disjoint_confirmation_v1.json</a:t>
             </a:r>
           </a:p>
           <a:p xmlns:a="http://schemas.openxmlformats.org/drawingml/2006/main">
@@ -1161,7 +1161,7 @@
           </a:p>
           <a:p xmlns:a="http://schemas.openxmlformats.org/drawingml/2006/main">
             <a:r>
-              <a:t>这一页验证的是一个固定、可执行的 Gate 规则，不再为每条路线单独挑阈值。</a:t>
+              <a:t>这一页展示原 Gate 的失败，以及为什么改成限制 LLM 在线决策轮数。</a:t>
             </a:r>
           </a:p>
           <a:p xmlns:a="http://schemas.openxmlformats.org/drawingml/2006/main">
@@ -1176,7 +1176,7 @@
           </a:p>
           <a:p xmlns:a="http://schemas.openxmlformats.org/drawingml/2006/main">
             <a:r>
-              <a:t>规则只有三个部分：在第三轮评估；所有路线共用预测 MAE 阈值 5；如果 LLM 明确证伪或停止迁移，也直接触发。触发后系统保留初始观测和前三轮 LLM 已经做过的实验，再由 target-only GP-UCB 完成剩余 7 轮，不重启，也不拼接另一条独立轨迹。固定规则在 10/11 条路线触发，相对 target GP 的平均 AUC 增益从 +1.753 提到 +2.135，区间为 [+0.515,+4.001]，胜平负从 6/2/3 变为 6/3/2。相对原 LLM 的额外 +0.381 区间仍跨 0；相对每条路线事后最强 baseline 仍为 -0.168。在这些保存轨迹的反事实回放中，Gate 替换了 70 个后续 LLM 决策轮次，对应 140 次 proposer/critic 逻辑调用；这不是已经发生的付费节省。因此它目前证明的是“减少负迁移并节省后续 LLM 调用的可行性”，不是普遍超过所有 baseline。这里使用的是既有单条轨迹的 retrospective replay；真正的 prospective 结论要等冻结的 330 条新轨迹完成。</a:t>
+              <a:t>图中的六条路线完全不参与控制器选择。灰色圆点是完整 10 轮在线 LLM，均值相对 target GP 为 -1.056；橙色方块是开发路线中表现不错的第三轮阈值 5 Gate，但在这六条路线中降到 -1.968，说明预测误差阈值并不稳健，尤其 phonons 到 perovskites 在第三轮交接已经太晚。随后我们只用另外 11 条训练路线比较 115 个候选策略，按“先减少负向路线、再看平均值和最差路线、最后偏好更简单策略”的固定规则，选中单轮 LLM 控制器。绿色菱形是冻结后在六条分离路线上的结果：均值 +0.612，2 胜、3 平、1 负；相对完整 LLM 改善 +1.668。它的 95% 区间仍跨 0，而且仍输给部分更强的事后 baseline，所以本页支持的是一个机制假设：LLM 的语义判断适合前期定方向，后续连续数值优化应交给稳定的 GP。真正的统计结论要等待 6×30 新轨迹完成。</a:t>
             </a:r>
           </a:p>
           <a:p xmlns:a="http://schemas.openxmlformats.org/drawingml/2006/main">
@@ -1196,22 +1196,27 @@
           </a:p>
           <a:p xmlns:a="http://schemas.openxmlformats.org/drawingml/2006/main">
             <a:r>
+              <a:t>- experiments/care_replay/scripts/build_online_llm_gate_selection_audit.py</a:t>
+            </a:r>
+          </a:p>
+          <a:p xmlns:a="http://schemas.openxmlformats.org/drawingml/2006/main">
+            <a:r>
               <a:t>- experiments/care_replay/scripts/run_online_llm_scientist.py</a:t>
             </a:r>
           </a:p>
           <a:p xmlns:a="http://schemas.openxmlformats.org/drawingml/2006/main">
             <a:r>
-              <a:t>- experiments/care_replay/configs/online_llm_gated_repeated_confirmation_v1.json</a:t>
-            </a:r>
-          </a:p>
-          <a:p xmlns:a="http://schemas.openxmlformats.org/drawingml/2006/main">
-            <a:r>
-              <a:t>- experiments/care_replay/results/2026-08-24-online-llm-fixed-threshold5-gate-replay-v1/aggregate.json</a:t>
-            </a:r>
-          </a:p>
-          <a:p xmlns:a="http://schemas.openxmlformats.org/drawingml/2006/main">
-            <a:r>
-              <a:t>- experiments/care_replay/results/2026-08-24-online-llm-fixed-threshold5-gate-replay-v1/route_results.csv</a:t>
+              <a:t>- experiments/care_replay/configs/online_llm_bounded_authority_route_disjoint_confirmation_v1.json</a:t>
+            </a:r>
+          </a:p>
+          <a:p xmlns:a="http://schemas.openxmlformats.org/drawingml/2006/main">
+            <a:r>
+              <a:t>- experiments/care_replay/results/2026-08-24-online-llm-route-split-gate-selection-v1/selected_policy.json</a:t>
+            </a:r>
+          </a:p>
+          <a:p xmlns:a="http://schemas.openxmlformats.org/drawingml/2006/main">
+            <a:r>
+              <a:t>- experiments/care_replay/results/2026-08-24-online-llm-route-split-gate-selection-v1/selected_policy_evaluation_routes.jsonl</a:t>
             </a:r>
           </a:p>
         </p:txBody>
@@ -2164,7 +2169,7 @@
   </p:cSld>
   <p:clrMap bg1="lt1" tx1="dk1" bg2="lt2" tx2="dk2" accent1="accent1" accent2="accent2" accent3="accent3" accent4="accent4" accent5="accent5" accent6="accent6" hlink="hlink" folHlink="folHlink"/>
   <p:sldLayoutIdLst>
-    <p:sldLayoutId xmlns:r="http://schemas.openxmlformats.org/officeDocument/2006/relationships" id="2147483649" r:id="R70e76383c491476c"/>
+    <p:sldLayoutId xmlns:r="http://schemas.openxmlformats.org/officeDocument/2006/relationships" id="2147483649" r:id="Rc136ae6fa29942eb"/>
   </p:sldLayoutIdLst>
   <p:txStyles>
     <p:titleStyle>
@@ -3736,7 +3741,7 @@
           <p:nvPr/>
         </p:nvPicPr>
         <p:blipFill>
-          <a:blip xmlns:r="http://schemas.openxmlformats.org/officeDocument/2006/relationships" xmlns:a="http://schemas.openxmlformats.org/drawingml/2006/main" r:embed="Rcd437d84c97f4b92"/>
+          <a:blip xmlns:r="http://schemas.openxmlformats.org/officeDocument/2006/relationships" xmlns:a="http://schemas.openxmlformats.org/drawingml/2006/main" r:embed="R12ce783d673c4567"/>
           <a:stretch xmlns:a="http://schemas.openxmlformats.org/drawingml/2006/main"/>
         </p:blipFill>
         <p:spPr>
@@ -3820,7 +3825,7 @@
           <p:nvPr/>
         </p:nvPicPr>
         <p:blipFill>
-          <a:blip xmlns:r="http://schemas.openxmlformats.org/officeDocument/2006/relationships" xmlns:a="http://schemas.openxmlformats.org/drawingml/2006/main" r:embed="R164c0e5f0a99401d"/>
+          <a:blip xmlns:r="http://schemas.openxmlformats.org/officeDocument/2006/relationships" xmlns:a="http://schemas.openxmlformats.org/drawingml/2006/main" r:embed="R4ae0710e361d43f5"/>
           <a:srcRect xmlns:a="http://schemas.openxmlformats.org/drawingml/2006/main" l="0" t="0" r="0" b="0"/>
           <a:stretch xmlns:a="http://schemas.openxmlformats.org/drawingml/2006/main"/>
         </p:blipFill>
@@ -4089,7 +4094,7 @@
           <p:nvPr/>
         </p:nvPicPr>
         <p:blipFill>
-          <a:blip xmlns:r="http://schemas.openxmlformats.org/officeDocument/2006/relationships" xmlns:a="http://schemas.openxmlformats.org/drawingml/2006/main" r:embed="Rceafa317a5bf4aa6"/>
+          <a:blip xmlns:r="http://schemas.openxmlformats.org/officeDocument/2006/relationships" xmlns:a="http://schemas.openxmlformats.org/drawingml/2006/main" r:embed="R4927d05df26e415b"/>
           <a:stretch xmlns:a="http://schemas.openxmlformats.org/drawingml/2006/main"/>
         </p:blipFill>
         <p:spPr>
@@ -4173,7 +4178,7 @@
           <p:nvPr/>
         </p:nvPicPr>
         <p:blipFill>
-          <a:blip xmlns:r="http://schemas.openxmlformats.org/officeDocument/2006/relationships" xmlns:a="http://schemas.openxmlformats.org/drawingml/2006/main" r:embed="Re5cb42b65cf3408d"/>
+          <a:blip xmlns:r="http://schemas.openxmlformats.org/officeDocument/2006/relationships" xmlns:a="http://schemas.openxmlformats.org/drawingml/2006/main" r:embed="Ra15e56223a4945e2"/>
           <a:srcRect xmlns:a="http://schemas.openxmlformats.org/drawingml/2006/main" l="0" t="0" r="0" b="0"/>
           <a:stretch xmlns:a="http://schemas.openxmlformats.org/drawingml/2006/main"/>
         </p:blipFill>
@@ -4442,7 +4447,7 @@
           <p:nvPr/>
         </p:nvPicPr>
         <p:blipFill>
-          <a:blip xmlns:r="http://schemas.openxmlformats.org/officeDocument/2006/relationships" xmlns:a="http://schemas.openxmlformats.org/drawingml/2006/main" r:embed="R7a6e0fab6bbc4df3"/>
+          <a:blip xmlns:r="http://schemas.openxmlformats.org/officeDocument/2006/relationships" xmlns:a="http://schemas.openxmlformats.org/drawingml/2006/main" r:embed="Rc26688f678734eab"/>
           <a:stretch xmlns:a="http://schemas.openxmlformats.org/drawingml/2006/main"/>
         </p:blipFill>
         <p:spPr>
@@ -4526,7 +4531,7 @@
           <p:nvPr/>
         </p:nvPicPr>
         <p:blipFill>
-          <a:blip xmlns:r="http://schemas.openxmlformats.org/officeDocument/2006/relationships" xmlns:a="http://schemas.openxmlformats.org/drawingml/2006/main" r:embed="R821aa8c174074148"/>
+          <a:blip xmlns:r="http://schemas.openxmlformats.org/officeDocument/2006/relationships" xmlns:a="http://schemas.openxmlformats.org/drawingml/2006/main" r:embed="Rcb9628a3dcdd4303"/>
           <a:srcRect xmlns:a="http://schemas.openxmlformats.org/drawingml/2006/main" l="0" t="12000" r="0" b="0"/>
           <a:stretch xmlns:a="http://schemas.openxmlformats.org/drawingml/2006/main"/>
         </p:blipFill>
@@ -4647,8 +4652,8 @@
         </p:nvSpPr>
         <p:spPr>
           <a:xfrm xmlns:a="http://schemas.openxmlformats.org/drawingml/2006/main">
-            <a:off x="11258550" y="266700"/>
-            <a:ext cx="285750" cy="171450"/>
+            <a:off x="11163300" y="266700"/>
+            <a:ext cx="381000" cy="171450"/>
           </a:xfrm>
           <a:prstGeom xmlns:a="http://schemas.openxmlformats.org/drawingml/2006/main" prst="rect">
             <a:avLst/>
@@ -4750,7 +4755,7 @@
                 <a:ea typeface="Arial Unicode MS"/>
                 <a:cs typeface="Arial Unicode MS"/>
               </a:rPr>
-              <a:t>当前证据支持“路线特异的正向信号”，不支持“普遍跨领域提升”</a:t>
+              <a:t>LLM 更适合前期提出方向，而不是长期接管优化</a:t>
             </a:r>
           </a:p>
         </p:txBody>
@@ -4963,7 +4968,7 @@
                 <a:ea typeface="Arial Unicode MS"/>
                 <a:cs typeface="Arial Unicode MS"/>
               </a:rPr>
-              <a:t>• 11 路线均值 +1.75；固定 Gate 后 +2.13</a:t>
+              <a:t>• 11 路线有正向信号；17 路线仍不确定</a:t>
             </a:r>
           </a:p>
           <a:p xmlns:a="http://schemas.openxmlformats.org/drawingml/2006/main">
@@ -4990,7 +4995,7 @@
                 <a:ea typeface="Arial Unicode MS"/>
                 <a:cs typeface="Arial Unicode MS"/>
               </a:rPr>
-              <a:t>• 17 路线完整盘点均值 +0.76</a:t>
+              <a:t>• 固定 Gate 在分离路线失效</a:t>
             </a:r>
           </a:p>
           <a:p xmlns:a="http://schemas.openxmlformats.org/drawingml/2006/main">
@@ -5017,7 +5022,7 @@
                 <a:ea typeface="Arial Unicode MS"/>
                 <a:cs typeface="Arial Unicode MS"/>
               </a:rPr>
-              <a:t>• prompt、选择、结果和失败可追溯</a:t>
+              <a:t>• 单轮 LLM：6 路线均值 +0.61</a:t>
             </a:r>
           </a:p>
         </p:txBody>
@@ -5582,7 +5587,7 @@
                 <a:ea typeface="Arial Unicode MS"/>
                 <a:cs typeface="Arial Unicode MS"/>
               </a:rPr>
-              <a:t>一句话：LLM 在冻结子集上有平均正向信号，校准可降低负迁移风险；</a:t>
+              <a:t>一句话：一次 LLM 语义决策后交回 GP，在分离路线中更稳；</a:t>
             </a:r>
           </a:p>
           <a:p xmlns:a="http://schemas.openxmlformats.org/drawingml/2006/main">
@@ -5609,7 +5614,7 @@
                 <a:ea typeface="Arial Unicode MS"/>
                 <a:cs typeface="Arial Unicode MS"/>
               </a:rPr>
-              <a:t>完整历史盘点和强 baseline 仍不支持“普遍优于现有方法”。</a:t>
+              <a:t>但区间仍跨 0，不能说已经普遍提升。</a:t>
             </a:r>
           </a:p>
         </p:txBody>
@@ -6041,7 +6046,7 @@
                 <a:ea typeface="Arial Unicode MS"/>
                 <a:cs typeface="Arial Unicode MS"/>
               </a:rPr>
-              <a:t>已冻结前瞻 Gate 协议</a:t>
+              <a:t>已冻结单轮 LLM 确认协议</a:t>
             </a:r>
           </a:p>
         </p:txBody>
@@ -6103,7 +6108,7 @@
                 <a:ea typeface="Arial Unicode MS"/>
                 <a:cs typeface="Arial Unicode MS"/>
               </a:rPr>
-              <a:t>11 路线 × 30 次；第 3 轮、阈值 5、无 optional stopping。</a:t>
+              <a:t>6 路线 × 30 次；LLM 决策 1 轮，之后交回 GP；无 optional stopping。</a:t>
             </a:r>
           </a:p>
         </p:txBody>
@@ -7155,7 +7160,7 @@
                 <a:ea typeface="Arial Unicode MS"/>
                 <a:cs typeface="Arial Unicode MS"/>
               </a:rPr>
-              <a:t>固定阈值 Gate</a:t>
+              <a:t>从失败 Gate 到单轮 LLM</a:t>
             </a:r>
           </a:p>
         </p:txBody>
@@ -7279,7 +7284,7 @@
                 <a:ea typeface="Arial Unicode MS"/>
                 <a:cs typeface="Arial Unicode MS"/>
               </a:rPr>
-              <a:t>全局阈值 5：平均增益 +1.75 → +2.13，负向路线 3 → 2</a:t>
+              <a:t>分离路线：完整 LLM -1.06；阈值 Gate -1.97；单轮 LLM +0.61</a:t>
             </a:r>
           </a:p>
         </p:txBody>
@@ -7324,7 +7329,7 @@
           <p:nvPr/>
         </p:nvPicPr>
         <p:blipFill>
-          <a:blip xmlns:r="http://schemas.openxmlformats.org/officeDocument/2006/relationships" xmlns:a="http://schemas.openxmlformats.org/drawingml/2006/main" r:embed="R5475b1205acc414b"/>
+          <a:blip xmlns:r="http://schemas.openxmlformats.org/officeDocument/2006/relationships" xmlns:a="http://schemas.openxmlformats.org/drawingml/2006/main" r:embed="R1126e8dde87041ab"/>
           <a:stretch xmlns:a="http://schemas.openxmlformats.org/drawingml/2006/main"/>
         </p:blipFill>
         <p:spPr>
@@ -7408,7 +7413,7 @@
           <p:nvPr/>
         </p:nvPicPr>
         <p:blipFill>
-          <a:blip xmlns:r="http://schemas.openxmlformats.org/officeDocument/2006/relationships" xmlns:a="http://schemas.openxmlformats.org/drawingml/2006/main" r:embed="Rf43e94c7090c4ebd"/>
+          <a:blip xmlns:r="http://schemas.openxmlformats.org/officeDocument/2006/relationships" xmlns:a="http://schemas.openxmlformats.org/drawingml/2006/main" r:embed="R1a7cb55ef7d3424e"/>
           <a:srcRect xmlns:a="http://schemas.openxmlformats.org/drawingml/2006/main" l="0" t="0" r="0" b="0"/>
           <a:stretch xmlns:a="http://schemas.openxmlformats.org/drawingml/2006/main"/>
         </p:blipFill>

</xml_diff>

<commit_message>
experiments: audit live LLM decision impact
</commit_message>
<xml_diff>
--- a/CARE2.0_Nature_evidence_update_2026-08-24.pptx
+++ b/CARE2.0_Nature_evidence_update_2026-08-24.pptx
@@ -2,27 +2,27 @@
 <file path=ppt/presentation.xml><?xml version="1.0" encoding="utf-8"?>
 <p:presentation xmlns:p="http://schemas.openxmlformats.org/presentationml/2006/main">
   <p:sldMasterIdLst>
-    <p:sldMasterId xmlns:r="http://schemas.openxmlformats.org/officeDocument/2006/relationships" id="2147483648" r:id="Rcae0aef4663c4396"/>
+    <p:sldMasterId xmlns:r="http://schemas.openxmlformats.org/officeDocument/2006/relationships" id="2147483648" r:id="R7b94c81234e84037"/>
   </p:sldMasterIdLst>
   <p:notesMasterIdLst>
-    <p:notesMasterId xmlns:r="http://schemas.openxmlformats.org/officeDocument/2006/relationships" r:id="R85449462af104264"/>
+    <p:notesMasterId xmlns:r="http://schemas.openxmlformats.org/officeDocument/2006/relationships" r:id="R56d78e29f4314b94"/>
   </p:notesMasterIdLst>
   <p:sldIdLst>
-    <p:sldId xmlns:r="http://schemas.openxmlformats.org/officeDocument/2006/relationships" id="256" r:id="R3d088e0cfd544c83"/>
-    <p:sldId xmlns:r="http://schemas.openxmlformats.org/officeDocument/2006/relationships" id="257" r:id="R8aac0b5cda464252"/>
-    <p:sldId xmlns:r="http://schemas.openxmlformats.org/officeDocument/2006/relationships" id="258" r:id="Ra60f19e405c740fd"/>
-    <p:sldId xmlns:r="http://schemas.openxmlformats.org/officeDocument/2006/relationships" id="259" r:id="Ra142c86427944056"/>
-    <p:sldId xmlns:r="http://schemas.openxmlformats.org/officeDocument/2006/relationships" id="260" r:id="Rb4e26669f8394dc2"/>
-    <p:sldId xmlns:r="http://schemas.openxmlformats.org/officeDocument/2006/relationships" id="261" r:id="R22093593588f4c40"/>
-    <p:sldId xmlns:r="http://schemas.openxmlformats.org/officeDocument/2006/relationships" id="262" r:id="R7e8cab31458a4390"/>
-    <p:sldId xmlns:r="http://schemas.openxmlformats.org/officeDocument/2006/relationships" id="263" r:id="Rae3789ef306c41b2"/>
-    <p:sldId xmlns:r="http://schemas.openxmlformats.org/officeDocument/2006/relationships" id="264" r:id="R2866aafcedfc40c0"/>
-    <p:sldId xmlns:r="http://schemas.openxmlformats.org/officeDocument/2006/relationships" id="265" r:id="Rdf72775c286043a0"/>
-    <p:sldId xmlns:r="http://schemas.openxmlformats.org/officeDocument/2006/relationships" id="266" r:id="R49843bea4b0747a6"/>
-    <p:sldId xmlns:r="http://schemas.openxmlformats.org/officeDocument/2006/relationships" id="267" r:id="R8e6a1c3b99484b09"/>
-    <p:sldId xmlns:r="http://schemas.openxmlformats.org/officeDocument/2006/relationships" id="268" r:id="R2a759f1cbcae4eb4"/>
-    <p:sldId xmlns:r="http://schemas.openxmlformats.org/officeDocument/2006/relationships" id="269" r:id="R59cdf3db573049bc"/>
-    <p:sldId xmlns:r="http://schemas.openxmlformats.org/officeDocument/2006/relationships" id="270" r:id="R155f3b6be5214d3b"/>
+    <p:sldId xmlns:r="http://schemas.openxmlformats.org/officeDocument/2006/relationships" id="256" r:id="R822cd5d5fa874190"/>
+    <p:sldId xmlns:r="http://schemas.openxmlformats.org/officeDocument/2006/relationships" id="257" r:id="R21d8a5f0df8940f7"/>
+    <p:sldId xmlns:r="http://schemas.openxmlformats.org/officeDocument/2006/relationships" id="258" r:id="Ra3b0814e74b44a81"/>
+    <p:sldId xmlns:r="http://schemas.openxmlformats.org/officeDocument/2006/relationships" id="259" r:id="R01b5825892c2431d"/>
+    <p:sldId xmlns:r="http://schemas.openxmlformats.org/officeDocument/2006/relationships" id="260" r:id="R7ecff02788fd4ae1"/>
+    <p:sldId xmlns:r="http://schemas.openxmlformats.org/officeDocument/2006/relationships" id="261" r:id="R4f24516b757c46bb"/>
+    <p:sldId xmlns:r="http://schemas.openxmlformats.org/officeDocument/2006/relationships" id="262" r:id="R9bd792387e40491c"/>
+    <p:sldId xmlns:r="http://schemas.openxmlformats.org/officeDocument/2006/relationships" id="263" r:id="R66e993be55544177"/>
+    <p:sldId xmlns:r="http://schemas.openxmlformats.org/officeDocument/2006/relationships" id="264" r:id="Rced3db1bace9411e"/>
+    <p:sldId xmlns:r="http://schemas.openxmlformats.org/officeDocument/2006/relationships" id="265" r:id="R79d29986ff1f40e6"/>
+    <p:sldId xmlns:r="http://schemas.openxmlformats.org/officeDocument/2006/relationships" id="266" r:id="R5b7c95514cf746d4"/>
+    <p:sldId xmlns:r="http://schemas.openxmlformats.org/officeDocument/2006/relationships" id="267" r:id="Ra64cbaed803e41ac"/>
+    <p:sldId xmlns:r="http://schemas.openxmlformats.org/officeDocument/2006/relationships" id="268" r:id="R7af949a1715142a8"/>
+    <p:sldId xmlns:r="http://schemas.openxmlformats.org/officeDocument/2006/relationships" id="269" r:id="Rd3c7e018e33b4f89"/>
+    <p:sldId xmlns:r="http://schemas.openxmlformats.org/officeDocument/2006/relationships" id="270" r:id="Rb06acd3b3b8b40ab"/>
   </p:sldIdLst>
   <p:sldSz cx="12192000" cy="6858000"/>
   <p:notesSz cx="6858000" cy="9144000"/>
@@ -461,7 +461,7 @@
           </a:p>
           <a:p xmlns:a="http://schemas.openxmlformats.org/drawingml/2006/main">
             <a:r>
-              <a:t>CARE 2.0 的重点不是让大模型一次性猜答案，而是让它在每一轮新证据出现后修正假设并决定下一次实验。</a:t>
+              <a:t>CARE 2.0 的主线不是让大模型持续接管数值优化，而是让它把 source evidence 编译成可检查、可执行、可拒绝的迁移 skill。</a:t>
             </a:r>
           </a:p>
           <a:p xmlns:a="http://schemas.openxmlformats.org/drawingml/2006/main">
@@ -476,7 +476,7 @@
           </a:p>
           <a:p xmlns:a="http://schemas.openxmlformats.org/drawingml/2006/main">
             <a:r>
-              <a:t>系统先读取旧任务的数据和规律，把它们变成对新任务的可检验假设。新任务开始后，每次只执行一个实验；真实结果回来以后，模型要重新判断旧经验是否还适用。这样，迁移不是固定规则，而是一个可以被证据支持、削弱或拒绝的在线过程。</a:t>
+              <a:t>LLM 读取旧任务证据和新任务的公开 schema，提出规则特征、先验方向和搜索策略。Strict compiler 先检查字段和值是否存在，calibration split 再决定 skill 是否值得部署；冻结后由 target optimizer 在真实预算内执行。这样，LLM 提供语义和假设，GP 提供稳定的数值优化，失败 skill 可以被拒绝并保留审计记录。在线 proposer/critic 仍然存在，但首批真实 pilot 没有改变 GP rank 1，因此目前是探索模块，不是论文主贡献。</a:t>
             </a:r>
           </a:p>
           <a:p xmlns:a="http://schemas.openxmlformats.org/drawingml/2006/main">
@@ -491,12 +491,22 @@
           </a:p>
           <a:p xmlns:a="http://schemas.openxmlformats.org/drawingml/2006/main">
             <a:r>
-              <a:t>- experiments/care_replay/CARE2_METHOD.md</a:t>
-            </a:r>
-          </a:p>
-          <a:p xmlns:a="http://schemas.openxmlformats.org/drawingml/2006/main">
-            <a:r>
-              <a:t>- experiments/care_replay/scripts/run_online_llm_scientist.py</a:t>
+              <a:t>- experiments/care_replay/results/2026-07-21-cross-domain-semantic-skills/README.md</a:t>
+            </a:r>
+          </a:p>
+          <a:p xmlns:a="http://schemas.openxmlformats.org/drawingml/2006/main">
+            <a:r>
+              <a:t>- experiments/care_replay/scripts/generate_llm_semantic_skills.py</a:t>
+            </a:r>
+          </a:p>
+          <a:p xmlns:a="http://schemas.openxmlformats.org/drawingml/2006/main">
+            <a:r>
+              <a:t>- experiments/care_replay/scripts/run_calibrated_llm_semantic_selector.py</a:t>
+            </a:r>
+          </a:p>
+          <a:p xmlns:a="http://schemas.openxmlformats.org/drawingml/2006/main">
+            <a:r>
+              <a:t>- docs/NATURE_SUBMISSION_READINESS.md</a:t>
             </a:r>
           </a:p>
         </p:txBody>
@@ -926,7 +936,7 @@
           </a:p>
           <a:p xmlns:a="http://schemas.openxmlformats.org/drawingml/2006/main">
             <a:r>
-              <a:t>这页把已完成的工程能力、当前统计证据和仍缺失的前瞻证据分开。</a:t>
+              <a:t>这页重新排列证据层级：LLM 编译可执行 skill 是当前主贡献，在线候选选择仍是探索模块。</a:t>
             </a:r>
           </a:p>
           <a:p xmlns:a="http://schemas.openxmlformats.org/drawingml/2006/main">
@@ -941,7 +951,7 @@
           </a:p>
           <a:p xmlns:a="http://schemas.openxmlformats.org/drawingml/2006/main">
             <a:r>
-              <a:t>冻结 11 路线中，原始在线 LLM 相对同开局 target-only GP-UCB 的平均 best-so-far AUC 增益为 +1.753；完整 17 路线盘点降到 +0.762，区间跨 0。更严格的六条分离路线没有参与策略选择：完整 LLM 均值为 -1.056，第三轮阈值 5 Gate 为 -1.968，说明原 Gate 在开发路线上的改善不能外推。用 11 条训练路线比较 115 个控制器后，训练规则选出“LLM 在线决策一轮，随后交回 GP”；它在六条分离路线中的均值为 +0.612，2 胜、3 平、1 负，但区间仍跨 0。因此当前最准确定位是“找到了一个更合理、需要前瞻验证的 LLM 介入边界”。</a:t>
+              <a:t>现有最扎实的 LLM 证据来自 frozen semantic-skill compiler。LLM 读取 source evidence 和 target public schema，生成规则特征、先验方向与 acquisition schedule；strict compiler 检查字段和值，calibration split 决定是否部署，held-out replay 不再调用 LLM。相对 strongest target-only anchor，FreeSolv、Buchwald-Hartwig 和 Matbench band gap 的 AUC 分别提高 +1.384、+2.859 和 +5.930。schedule-only 与 no-prior 同 seed 消融说明 semantic representation 和 prior direction 都有独立贡献；ChemLex 的负结果没有被提升为确认结论。相反，首批六条真实在线轨迹全部选择 GP rank 1，在线增量为 0。因此不能把“模型有回复”当作“模型改变了实验”。论文主线应聚焦 LLM 编译的可执行 skill，在线 proposer/critic 只作为仍待验证的假设修订与 abstention 模块。</a:t>
             </a:r>
           </a:p>
           <a:p xmlns:a="http://schemas.openxmlformats.org/drawingml/2006/main">
@@ -961,12 +971,12 @@
           </a:p>
           <a:p xmlns:a="http://schemas.openxmlformats.org/drawingml/2006/main">
             <a:r>
-              <a:t>- experiments/care_replay/results/2026-08-24-online-llm-predeclared-baseline-portfolio-v2/aggregate.json</a:t>
-            </a:r>
-          </a:p>
-          <a:p xmlns:a="http://schemas.openxmlformats.org/drawingml/2006/main">
-            <a:r>
-              <a:t>- experiments/care_replay/results/2026-08-24-online-llm-route-split-gate-selection-v1/selected_policy.json</a:t>
+              <a:t>- experiments/care_replay/results/2026-07-21-cross-domain-semantic-skills/README.md</a:t>
+            </a:r>
+          </a:p>
+          <a:p xmlns:a="http://schemas.openxmlformats.org/drawingml/2006/main">
+            <a:r>
+              <a:t>- experiments/care_replay/results/2026-08-24-online-llm-bounded-authority-route-disjoint-confirmation-v1/pilot_audit/decision_impact_audit.json</a:t>
             </a:r>
           </a:p>
         </p:txBody>
@@ -1041,7 +1051,7 @@
           </a:p>
           <a:p xmlns:a="http://schemas.openxmlformats.org/drawingml/2006/main">
             <a:r>
-              <a:t>单轮 LLM 的运行时交接已经接入代码，并且重复确认协议已经在新调用前冻结。</a:t>
+              <a:t>下一步不是继续堆在线调用，而是先证明 LLM 的输出确实改变动作，并把 semantic skill 放到新任务上做冻结验证。</a:t>
             </a:r>
           </a:p>
           <a:p xmlns:a="http://schemas.openxmlformats.org/drawingml/2006/main">
@@ -1056,7 +1066,7 @@
           </a:p>
           <a:p xmlns:a="http://schemas.openxmlformats.org/drawingml/2006/main">
             <a:r>
-              <a:t>协议包含 6 条没有参与控制器选择的 source-target 路线，每条 30 次，共 180 条新随机轨迹。每条轨迹使用相同初始观测、10 轮预算、Opus 4.8 proposer + critic 和同开局 target-only GP。LLM 只控制第一次在线 reveal；从第二轮开始不再调用 LLM，由 target-only GP-UCB 从初始观测和第一轮结果继续。协议禁止根据中间结果删路线、改控制器或提前停止。必须完成全部 180 条轨迹，才计算主要层级 bootstrap 结论。路线名称和每条路线的一条旧轨迹此前已知，因此即使完成也属于内部重复确认，不是外部新任务或 wet-lab 证明。</a:t>
+              <a:t>在线 pilot 的 6 个成功调用共消耗 99,243 tokens，但 6 次都选择 GP rank 1，说明直接扩成 180 次只会高成本重复无决策影响的策略。该启动还保留了一次 inactive-key 的 pre-response 失败，按冻结 retry semantics 已经无法满足原来的完整确认条件。下一步先只在 development routes 上开发 challenger 或 semantic skill policy，要求出现非零且有益的 action change；随后在新任务上冻结 skill、compiler、数据 split、baseline 和统计口径，再开始 disjoint evaluation。与此同时必须补 RGPE、multitask GP 等同预算强 baseline、source evidence / semantic rule / prior / critic 的同 seed 消融，以及至少一条 prospective wet-lab campaign。</a:t>
             </a:r>
           </a:p>
           <a:p xmlns:a="http://schemas.openxmlformats.org/drawingml/2006/main">
@@ -1071,22 +1081,17 @@
           </a:p>
           <a:p xmlns:a="http://schemas.openxmlformats.org/drawingml/2006/main">
             <a:r>
-              <a:t>- experiments/care_replay/configs/online_llm_bounded_authority_route_disjoint_confirmation_v1.json</a:t>
-            </a:r>
-          </a:p>
-          <a:p xmlns:a="http://schemas.openxmlformats.org/drawingml/2006/main">
-            <a:r>
-              <a:t>- experiments/care_replay/scripts/run_online_llm_scientist.py</a:t>
-            </a:r>
-          </a:p>
-          <a:p xmlns:a="http://schemas.openxmlformats.org/drawingml/2006/main">
-            <a:r>
-              <a:t>- experiments/care_replay/scripts/run_repeated_online_llm_confirmation.py</a:t>
-            </a:r>
-          </a:p>
-          <a:p xmlns:a="http://schemas.openxmlformats.org/drawingml/2006/main">
-            <a:r>
               <a:t>- docs/NATURE_SUBMISSION_READINESS.md</a:t>
+            </a:r>
+          </a:p>
+          <a:p xmlns:a="http://schemas.openxmlformats.org/drawingml/2006/main">
+            <a:r>
+              <a:t>- experiments/care_replay/results/2026-08-24-online-llm-bounded-authority-route-disjoint-confirmation-v1/pilot_audit/PILOT_RESULTS.md</a:t>
+            </a:r>
+          </a:p>
+          <a:p xmlns:a="http://schemas.openxmlformats.org/drawingml/2006/main">
+            <a:r>
+              <a:t>- experiments/care_replay/results/2026-07-21-cross-domain-semantic-skills/README.md</a:t>
             </a:r>
           </a:p>
         </p:txBody>
@@ -1161,7 +1166,7 @@
           </a:p>
           <a:p xmlns:a="http://schemas.openxmlformats.org/drawingml/2006/main">
             <a:r>
-              <a:t>这一页展示原 Gate 的失败，以及为什么改成限制 LLM 在线决策轮数。</a:t>
+              <a:t>这页回答一个更基本的问题：在线 LLM 真实调用后，是否改变了实验选择。</a:t>
             </a:r>
           </a:p>
           <a:p xmlns:a="http://schemas.openxmlformats.org/drawingml/2006/main">
@@ -1176,7 +1181,7 @@
           </a:p>
           <a:p xmlns:a="http://schemas.openxmlformats.org/drawingml/2006/main">
             <a:r>
-              <a:t>图中的六条路线完全不参与控制器选择。灰色圆点是完整 10 轮在线 LLM，均值相对 target GP 为 -1.056；橙色方块是开发路线中表现不错的第三轮阈值 5 Gate，但在这六条路线中降到 -1.968，说明预测误差阈值并不稳健，尤其 phonons 到 perovskites 在第三轮交接已经太晚。随后我们只用另外 11 条训练路线比较 115 个候选策略，按“先减少负向路线、再看平均值和最差路线、最后偏好更简单策略”的固定规则，选中单轮 LLM 控制器。绿色菱形是冻结后在六条分离路线上的结果：均值 +0.612，2 胜、3 平、1 负；相对完整 LLM 改善 +1.668。它的 95% 区间仍跨 0，而且仍输给部分更强的事后 baseline，所以本页支持的是一个机制假设：LLM 的语义判断适合前期定方向，后续连续数值优化应交给稳定的 GP。真正的统计结论要等待 6×30 新轨迹完成。</a:t>
+              <a:t>左图的橙色刻线表示在线 LLM 相对同开局 target-only GP 的 AUC 差值，六条路线全部为 0；蓝色条表示包含 LLM initial design 的 complete system 相对固定 initial design，三条正向、一条持平、两条负向，平均 -0.0087。右图直接检查行为：6 次都选择 GP rank 1，非 GP override 为 0，critic 改选为 0；其中 3 次文字上保留 source transfer，但并没有改变候选。六条成功轨迹共使用 99,243 tokens，单轮 authority limit 避免了 108 次后续名义调用。这证明 bounded authority 能省调用，却还不能证明在线 LLM 提高性能。当前需要优化的是 decision mechanism，不是继续增加相同调用次数。</a:t>
             </a:r>
           </a:p>
           <a:p xmlns:a="http://schemas.openxmlformats.org/drawingml/2006/main">
@@ -1191,32 +1196,17 @@
           </a:p>
           <a:p xmlns:a="http://schemas.openxmlformats.org/drawingml/2006/main">
             <a:r>
-              <a:t>- experiments/care_replay/scripts/build_online_llm_calibration_gate_audit.py</a:t>
-            </a:r>
-          </a:p>
-          <a:p xmlns:a="http://schemas.openxmlformats.org/drawingml/2006/main">
-            <a:r>
-              <a:t>- experiments/care_replay/scripts/build_online_llm_gate_selection_audit.py</a:t>
-            </a:r>
-          </a:p>
-          <a:p xmlns:a="http://schemas.openxmlformats.org/drawingml/2006/main">
-            <a:r>
-              <a:t>- experiments/care_replay/scripts/run_online_llm_scientist.py</a:t>
-            </a:r>
-          </a:p>
-          <a:p xmlns:a="http://schemas.openxmlformats.org/drawingml/2006/main">
-            <a:r>
-              <a:t>- experiments/care_replay/configs/online_llm_bounded_authority_route_disjoint_confirmation_v1.json</a:t>
-            </a:r>
-          </a:p>
-          <a:p xmlns:a="http://schemas.openxmlformats.org/drawingml/2006/main">
-            <a:r>
-              <a:t>- experiments/care_replay/results/2026-08-24-online-llm-route-split-gate-selection-v1/selected_policy.json</a:t>
-            </a:r>
-          </a:p>
-          <a:p xmlns:a="http://schemas.openxmlformats.org/drawingml/2006/main">
-            <a:r>
-              <a:t>- experiments/care_replay/results/2026-08-24-online-llm-route-split-gate-selection-v1/selected_policy_evaluation_routes.jsonl</a:t>
+              <a:t>- experiments/care_replay/scripts/build_online_llm_decision_impact_audit.py</a:t>
+            </a:r>
+          </a:p>
+          <a:p xmlns:a="http://schemas.openxmlformats.org/drawingml/2006/main">
+            <a:r>
+              <a:t>- experiments/care_replay/results/2026-08-24-online-llm-bounded-authority-route-disjoint-confirmation-v1/pilot_audit/decision_impact_audit.json</a:t>
+            </a:r>
+          </a:p>
+          <a:p xmlns:a="http://schemas.openxmlformats.org/drawingml/2006/main">
+            <a:r>
+              <a:t>- experiments/care_replay/results/2026-08-24-online-llm-bounded-authority-route-disjoint-confirmation-v1/pilot_audit/route_decision_metrics.csv</a:t>
             </a:r>
           </a:p>
         </p:txBody>
@@ -1511,7 +1501,7 @@
           </a:p>
           <a:p xmlns:a="http://schemas.openxmlformats.org/drawingml/2006/main">
             <a:r>
-              <a:t>LLM 在每一轮都有决策权。Proposer 先提案，Critic 再检查，最终只执行一个候选。</a:t>
+              <a:t>这页展示在线 proposer/critic 控制器，但它现在是被审计的探索模块，不是已确认的主方法。</a:t>
             </a:r>
           </a:p>
           <a:p xmlns:a="http://schemas.openxmlformats.org/drawingml/2006/main">
@@ -1526,7 +1516,7 @@
           </a:p>
           <a:p xmlns:a="http://schemas.openxmlformats.org/drawingml/2006/main">
             <a:r>
-              <a:t>候选菜单同时包含 target-only GP 的高分点、source prior 支持的点、共识点和覆盖点。Proposer 要更新一个可证伪假设并选一个实验；Critic 可以接受，也可以退回 GP rank 1，或在合格菜单中改选。真实结果揭示后，GP 后验、当前 best、假设状态和下一轮菜单一起更新。</a:t>
+              <a:t>候选菜单包含 target GP 高分点、source prior 支持点、共识点和覆盖点。Proposer 更新可证伪假设并提议一个实验；Critic 可以接受、退回 GP rank 1 或改选。历史完整在线版本允许 LLM 在十轮都有最终选择权，但分离路线表现不稳。Bounded pilot 因此只允许第一轮 LLM 决策，后九轮交回 target GP。首批六条真实调用中，LLM 六次都选择 GP rank 1，说明它输出了结构化判断，却没有产生 action change。</a:t>
             </a:r>
           </a:p>
           <a:p xmlns:a="http://schemas.openxmlformats.org/drawingml/2006/main">
@@ -1546,7 +1536,12 @@
           </a:p>
           <a:p xmlns:a="http://schemas.openxmlformats.org/drawingml/2006/main">
             <a:r>
-              <a:t>- experiments/care_replay/tests/test_online_llm_scientist.py</a:t>
+              <a:t>- experiments/care_replay/results/2026-08-24-online-llm-bounded-authority-route-disjoint-confirmation-v1/pilot_audit/decision_impact_audit.json</a:t>
+            </a:r>
+          </a:p>
+          <a:p xmlns:a="http://schemas.openxmlformats.org/drawingml/2006/main">
+            <a:r>
+              <a:t>- docs/NATURE_SUBMISSION_READINESS.md</a:t>
             </a:r>
           </a:p>
         </p:txBody>
@@ -2169,7 +2164,7 @@
   </p:cSld>
   <p:clrMap bg1="lt1" tx1="dk1" bg2="lt2" tx2="dk2" accent1="accent1" accent2="accent2" accent3="accent3" accent4="accent4" accent5="accent5" accent6="accent6" hlink="hlink" folHlink="folHlink"/>
   <p:sldLayoutIdLst>
-    <p:sldLayoutId xmlns:r="http://schemas.openxmlformats.org/officeDocument/2006/relationships" id="2147483649" r:id="Rc136ae6fa29942eb"/>
+    <p:sldLayoutId xmlns:r="http://schemas.openxmlformats.org/officeDocument/2006/relationships" id="2147483649" r:id="R9292690611cd47ef"/>
   </p:sldLayoutIdLst>
   <p:txStyles>
     <p:titleStyle>
@@ -2834,7 +2829,7 @@
                 <a:ea typeface="Arial Unicode MS"/>
                 <a:cs typeface="Arial Unicode MS"/>
               </a:rPr>
-              <a:t>让 LLM 在证据中持续修正</a:t>
+              <a:t>让 LLM 把历史经验编译成</a:t>
             </a:r>
           </a:p>
           <a:p xmlns:a="http://schemas.openxmlformats.org/drawingml/2006/main">
@@ -2861,7 +2856,7 @@
                 <a:ea typeface="Arial Unicode MS"/>
                 <a:cs typeface="Arial Unicode MS"/>
               </a:rPr>
-              <a:t>CARE 2.0</a:t>
+              <a:t>可验证的迁移 skill</a:t>
             </a:r>
           </a:p>
         </p:txBody>
@@ -2923,7 +2918,7 @@
                 <a:ea typeface="Arial Unicode MS"/>
                 <a:cs typeface="Arial Unicode MS"/>
               </a:rPr>
-              <a:t>历史知识提供假设，新实验逐轮决定是否继续迁移</a:t>
+              <a:t>先编译、再校准，冻结后交给目标优化器执行</a:t>
             </a:r>
           </a:p>
         </p:txBody>
@@ -3016,7 +3011,7 @@
                 <a:ea typeface="Arial Unicode MS"/>
                 <a:cs typeface="Arial Unicode MS"/>
               </a:rPr>
-              <a:t>在线 LLM Scientist · 真实重放证据 · 2026-08-24</a:t>
+              <a:t>LLM-generated skills · 真实数据与在线审计 · 2026-08-24</a:t>
             </a:r>
           </a:p>
         </p:txBody>
@@ -3233,7 +3228,7 @@
                 <a:ea typeface="Arial Unicode MS"/>
                 <a:cs typeface="Arial Unicode MS"/>
               </a:rPr>
-              <a:t>LLM 提假设</a:t>
+              <a:t>LLM 编 skill</a:t>
             </a:r>
           </a:p>
         </p:txBody>
@@ -3357,7 +3352,7 @@
                 <a:ea typeface="Arial Unicode MS"/>
                 <a:cs typeface="Arial Unicode MS"/>
               </a:rPr>
-              <a:t>逐轮实验</a:t>
+              <a:t>校准 / 拒绝</a:t>
             </a:r>
           </a:p>
         </p:txBody>
@@ -3481,7 +3476,7 @@
                 <a:ea typeface="Arial Unicode MS"/>
                 <a:cs typeface="Arial Unicode MS"/>
               </a:rPr>
-              <a:t>保存证据</a:t>
+              <a:t>目标优化</a:t>
             </a:r>
           </a:p>
         </p:txBody>
@@ -3741,7 +3736,7 @@
           <p:nvPr/>
         </p:nvPicPr>
         <p:blipFill>
-          <a:blip xmlns:r="http://schemas.openxmlformats.org/officeDocument/2006/relationships" xmlns:a="http://schemas.openxmlformats.org/drawingml/2006/main" r:embed="R12ce783d673c4567"/>
+          <a:blip xmlns:r="http://schemas.openxmlformats.org/officeDocument/2006/relationships" xmlns:a="http://schemas.openxmlformats.org/drawingml/2006/main" r:embed="R2a2e360ed2364957"/>
           <a:stretch xmlns:a="http://schemas.openxmlformats.org/drawingml/2006/main"/>
         </p:blipFill>
         <p:spPr>
@@ -3825,7 +3820,7 @@
           <p:nvPr/>
         </p:nvPicPr>
         <p:blipFill>
-          <a:blip xmlns:r="http://schemas.openxmlformats.org/officeDocument/2006/relationships" xmlns:a="http://schemas.openxmlformats.org/drawingml/2006/main" r:embed="R4ae0710e361d43f5"/>
+          <a:blip xmlns:r="http://schemas.openxmlformats.org/officeDocument/2006/relationships" xmlns:a="http://schemas.openxmlformats.org/drawingml/2006/main" r:embed="Rbb5c55b726cb4818"/>
           <a:srcRect xmlns:a="http://schemas.openxmlformats.org/drawingml/2006/main" l="0" t="0" r="0" b="0"/>
           <a:stretch xmlns:a="http://schemas.openxmlformats.org/drawingml/2006/main"/>
         </p:blipFill>
@@ -4094,7 +4089,7 @@
           <p:nvPr/>
         </p:nvPicPr>
         <p:blipFill>
-          <a:blip xmlns:r="http://schemas.openxmlformats.org/officeDocument/2006/relationships" xmlns:a="http://schemas.openxmlformats.org/drawingml/2006/main" r:embed="R4927d05df26e415b"/>
+          <a:blip xmlns:r="http://schemas.openxmlformats.org/officeDocument/2006/relationships" xmlns:a="http://schemas.openxmlformats.org/drawingml/2006/main" r:embed="R25551b6772f04c6e"/>
           <a:stretch xmlns:a="http://schemas.openxmlformats.org/drawingml/2006/main"/>
         </p:blipFill>
         <p:spPr>
@@ -4178,7 +4173,7 @@
           <p:nvPr/>
         </p:nvPicPr>
         <p:blipFill>
-          <a:blip xmlns:r="http://schemas.openxmlformats.org/officeDocument/2006/relationships" xmlns:a="http://schemas.openxmlformats.org/drawingml/2006/main" r:embed="Ra15e56223a4945e2"/>
+          <a:blip xmlns:r="http://schemas.openxmlformats.org/officeDocument/2006/relationships" xmlns:a="http://schemas.openxmlformats.org/drawingml/2006/main" r:embed="Rcaceb46f6af24abe"/>
           <a:srcRect xmlns:a="http://schemas.openxmlformats.org/drawingml/2006/main" l="0" t="0" r="0" b="0"/>
           <a:stretch xmlns:a="http://schemas.openxmlformats.org/drawingml/2006/main"/>
         </p:blipFill>
@@ -4447,7 +4442,7 @@
           <p:nvPr/>
         </p:nvPicPr>
         <p:blipFill>
-          <a:blip xmlns:r="http://schemas.openxmlformats.org/officeDocument/2006/relationships" xmlns:a="http://schemas.openxmlformats.org/drawingml/2006/main" r:embed="Rc26688f678734eab"/>
+          <a:blip xmlns:r="http://schemas.openxmlformats.org/officeDocument/2006/relationships" xmlns:a="http://schemas.openxmlformats.org/drawingml/2006/main" r:embed="R73f7bdb9b6bf4817"/>
           <a:stretch xmlns:a="http://schemas.openxmlformats.org/drawingml/2006/main"/>
         </p:blipFill>
         <p:spPr>
@@ -4531,7 +4526,7 @@
           <p:nvPr/>
         </p:nvPicPr>
         <p:blipFill>
-          <a:blip xmlns:r="http://schemas.openxmlformats.org/officeDocument/2006/relationships" xmlns:a="http://schemas.openxmlformats.org/drawingml/2006/main" r:embed="Rcb9628a3dcdd4303"/>
+          <a:blip xmlns:r="http://schemas.openxmlformats.org/officeDocument/2006/relationships" xmlns:a="http://schemas.openxmlformats.org/drawingml/2006/main" r:embed="R08ed687f58bd4e8e"/>
           <a:srcRect xmlns:a="http://schemas.openxmlformats.org/drawingml/2006/main" l="0" t="12000" r="0" b="0"/>
           <a:stretch xmlns:a="http://schemas.openxmlformats.org/drawingml/2006/main"/>
         </p:blipFill>
@@ -4755,7 +4750,7 @@
                 <a:ea typeface="Arial Unicode MS"/>
                 <a:cs typeface="Arial Unicode MS"/>
               </a:rPr>
-              <a:t>LLM 更适合前期提出方向，而不是长期接管优化</a:t>
+              <a:t>当前最强证据来自 LLM 生成的 skill，而不是在线选点</a:t>
             </a:r>
           </a:p>
         </p:txBody>
@@ -4941,7 +4936,7 @@
                 <a:ea typeface="Arial Unicode MS"/>
                 <a:cs typeface="Arial Unicode MS"/>
               </a:rPr>
-              <a:t>• 无泄漏 replay 与同预算对照</a:t>
+              <a:t>• LLM 编译 skill 已在 3 类真实任务获正向结果</a:t>
             </a:r>
           </a:p>
           <a:p xmlns:a="http://schemas.openxmlformats.org/drawingml/2006/main">
@@ -4968,7 +4963,7 @@
                 <a:ea typeface="Arial Unicode MS"/>
                 <a:cs typeface="Arial Unicode MS"/>
               </a:rPr>
-              <a:t>• 11 路线有正向信号；17 路线仍不确定</a:t>
+              <a:t>• 500 held-out seeds：AUC +1.38 / +2.86 / +5.93</a:t>
             </a:r>
           </a:p>
           <a:p xmlns:a="http://schemas.openxmlformats.org/drawingml/2006/main">
@@ -4995,7 +4990,7 @@
                 <a:ea typeface="Arial Unicode MS"/>
                 <a:cs typeface="Arial Unicode MS"/>
               </a:rPr>
-              <a:t>• 固定 Gate 在分离路线失效</a:t>
+              <a:t>• semantic rule 与 prior 消融均有贡献</a:t>
             </a:r>
           </a:p>
           <a:p xmlns:a="http://schemas.openxmlformats.org/drawingml/2006/main">
@@ -5022,7 +5017,7 @@
                 <a:ea typeface="Arial Unicode MS"/>
                 <a:cs typeface="Arial Unicode MS"/>
               </a:rPr>
-              <a:t>• 单轮 LLM：6 路线均值 +0.61</a:t>
+              <a:t>• ChemLex 负结果和全部 trace 保留</a:t>
             </a:r>
           </a:p>
         </p:txBody>
@@ -5177,7 +5172,7 @@
                 <a:ea typeface="Arial Unicode MS"/>
                 <a:cs typeface="Arial Unicode MS"/>
               </a:rPr>
-              <a:t>• 每条路线足量、独立的 LLM 重复</a:t>
+              <a:t>• 在线 pilot：6 / 6 选择 GP rank 1</a:t>
             </a:r>
           </a:p>
           <a:p xmlns:a="http://schemas.openxmlformats.org/drawingml/2006/main">
@@ -5204,7 +5199,7 @@
                 <a:ea typeface="Arial Unicode MS"/>
                 <a:cs typeface="Arial Unicode MS"/>
               </a:rPr>
-              <a:t>• 窄且不跨 0 的确认区间</a:t>
+              <a:t>• 在线 AUC 增量 0；override rate 0 / 6</a:t>
             </a:r>
           </a:p>
           <a:p xmlns:a="http://schemas.openxmlformats.org/drawingml/2006/main">
@@ -5231,7 +5226,7 @@
                 <a:ea typeface="Arial Unicode MS"/>
                 <a:cs typeface="Arial Unicode MS"/>
               </a:rPr>
-              <a:t>• 预先选型后稳定超过 transfer GP</a:t>
+              <a:t>• 真正未参与开发的新任务家族</a:t>
             </a:r>
           </a:p>
           <a:p xmlns:a="http://schemas.openxmlformats.org/drawingml/2006/main">
@@ -5258,7 +5253,7 @@
                 <a:ea typeface="Arial Unicode MS"/>
                 <a:cs typeface="Arial Unicode MS"/>
               </a:rPr>
-              <a:t>• 前瞻 wet-lab 独立验证</a:t>
+              <a:t>• source evidence 因果消融与前瞻 wet-lab</a:t>
             </a:r>
           </a:p>
         </p:txBody>
@@ -5413,7 +5408,7 @@
                 <a:ea typeface="Arial Unicode MS"/>
                 <a:cs typeface="Arial Unicode MS"/>
               </a:rPr>
-              <a:t>• 新结果更新状态、GP 和假设</a:t>
+              <a:t>• LLM 提出 skill，严格 compiler 执行</a:t>
             </a:r>
           </a:p>
           <a:p xmlns:a="http://schemas.openxmlformats.org/drawingml/2006/main">
@@ -5440,7 +5435,7 @@
                 <a:ea typeface="Arial Unicode MS"/>
                 <a:cs typeface="Arial Unicode MS"/>
               </a:rPr>
-              <a:t>• 证据不足时可关闭 source transfer</a:t>
+              <a:t>• calibration 只使用开发 split</a:t>
             </a:r>
           </a:p>
           <a:p xmlns:a="http://schemas.openxmlformats.org/drawingml/2006/main">
@@ -5494,7 +5489,7 @@
                 <a:ea typeface="Arial Unicode MS"/>
                 <a:cs typeface="Arial Unicode MS"/>
               </a:rPr>
-              <a:t>• trace 尚未自动蒸馏为永久 skill</a:t>
+              <a:t>• 在线 proposer / critic 仍是探索模块</a:t>
             </a:r>
           </a:p>
         </p:txBody>
@@ -5587,7 +5582,7 @@
                 <a:ea typeface="Arial Unicode MS"/>
                 <a:cs typeface="Arial Unicode MS"/>
               </a:rPr>
-              <a:t>一句话：一次 LLM 语义决策后交回 GP，在分离路线中更稳；</a:t>
+              <a:t>一句话：主线应是“LLM 把经验编译成可执行 skill，再由校准与 GP 安全执行”；</a:t>
             </a:r>
           </a:p>
           <a:p xmlns:a="http://schemas.openxmlformats.org/drawingml/2006/main">
@@ -5614,7 +5609,7 @@
                 <a:ea typeface="Arial Unicode MS"/>
                 <a:cs typeface="Arial Unicode MS"/>
               </a:rPr>
-              <a:t>但区间仍跨 0，不能说已经普遍提升。</a:t>
+              <a:t>在线 LLM 有完整 trace，但还没有证明会改善决策。</a:t>
             </a:r>
           </a:p>
         </p:txBody>
@@ -5891,7 +5886,7 @@
                 <a:ea typeface="Arial Unicode MS"/>
                 <a:cs typeface="Arial Unicode MS"/>
               </a:rPr>
-              <a:t>独立重复、强 baseline 与前瞻验证</a:t>
+              <a:t>先证明 LLM 改变了决策，再做大规模重复</a:t>
             </a:r>
           </a:p>
         </p:txBody>
@@ -6046,7 +6041,7 @@
                 <a:ea typeface="Arial Unicode MS"/>
                 <a:cs typeface="Arial Unicode MS"/>
               </a:rPr>
-              <a:t>已冻结单轮 LLM 确认协议</a:t>
+              <a:t>重做在线策略开发</a:t>
             </a:r>
           </a:p>
         </p:txBody>
@@ -6108,7 +6103,7 @@
                 <a:ea typeface="Arial Unicode MS"/>
                 <a:cs typeface="Arial Unicode MS"/>
               </a:rPr>
-              <a:t>6 路线 × 30 次；LLM 决策 1 轮，之后交回 GP；无 optional stopping。</a:t>
+              <a:t>当前 6 / 6 选择 GP rank 1；先在开发路线证明 override 有效。</a:t>
             </a:r>
           </a:p>
         </p:txBody>
@@ -6263,7 +6258,7 @@
                 <a:ea typeface="Arial Unicode MS"/>
                 <a:cs typeface="Arial Unicode MS"/>
               </a:rPr>
-              <a:t>重复强 baseline</a:t>
+              <a:t>冻结 semantic skill</a:t>
             </a:r>
           </a:p>
         </p:txBody>
@@ -6325,7 +6320,7 @@
                 <a:ea typeface="Arial Unicode MS"/>
                 <a:cs typeface="Arial Unicode MS"/>
               </a:rPr>
-              <a:t>并行重复 LLM、gated LLM、target GP、RGPE 与 multitask GP。</a:t>
+              <a:t>新任务上锁定 skill、compiler、split 与 baseline 后再看结果。</a:t>
             </a:r>
           </a:p>
         </p:txBody>
@@ -6697,7 +6692,7 @@
                 <a:ea typeface="Arial Unicode MS"/>
                 <a:cs typeface="Arial Unicode MS"/>
               </a:rPr>
-              <a:t>机制与消融</a:t>
+              <a:t>贡献归因</a:t>
             </a:r>
           </a:p>
         </p:txBody>
@@ -6759,7 +6754,7 @@
                 <a:ea typeface="Arial Unicode MS"/>
                 <a:cs typeface="Arial Unicode MS"/>
               </a:rPr>
-              <a:t>移除 source evidence、critic 或 gate，定位增益来自哪个模块。</a:t>
+              <a:t>移除 source evidence、semantic rule、prior 与 critic，做同 seed 消融。</a:t>
             </a:r>
           </a:p>
         </p:txBody>
@@ -7160,7 +7155,7 @@
                 <a:ea typeface="Arial Unicode MS"/>
                 <a:cs typeface="Arial Unicode MS"/>
               </a:rPr>
-              <a:t>从失败 Gate 到单轮 LLM</a:t>
+              <a:t>在线 LLM 首批真实调用</a:t>
             </a:r>
           </a:p>
         </p:txBody>
@@ -7284,7 +7279,7 @@
                 <a:ea typeface="Arial Unicode MS"/>
                 <a:cs typeface="Arial Unicode MS"/>
               </a:rPr>
-              <a:t>分离路线：完整 LLM -1.06；阈值 Gate -1.97；单轮 LLM +0.61</a:t>
+              <a:t>6 / 6 选择 GP rank 1；在线 AUC 增量 0；共使用 99,243 tokens</a:t>
             </a:r>
           </a:p>
         </p:txBody>
@@ -7329,7 +7324,7 @@
           <p:nvPr/>
         </p:nvPicPr>
         <p:blipFill>
-          <a:blip xmlns:r="http://schemas.openxmlformats.org/officeDocument/2006/relationships" xmlns:a="http://schemas.openxmlformats.org/drawingml/2006/main" r:embed="R1126e8dde87041ab"/>
+          <a:blip xmlns:r="http://schemas.openxmlformats.org/officeDocument/2006/relationships" xmlns:a="http://schemas.openxmlformats.org/drawingml/2006/main" r:embed="R36786a35ddac453a"/>
           <a:stretch xmlns:a="http://schemas.openxmlformats.org/drawingml/2006/main"/>
         </p:blipFill>
         <p:spPr>
@@ -7413,7 +7408,7 @@
           <p:nvPr/>
         </p:nvPicPr>
         <p:blipFill>
-          <a:blip xmlns:r="http://schemas.openxmlformats.org/officeDocument/2006/relationships" xmlns:a="http://schemas.openxmlformats.org/drawingml/2006/main" r:embed="R1a7cb55ef7d3424e"/>
+          <a:blip xmlns:r="http://schemas.openxmlformats.org/officeDocument/2006/relationships" xmlns:a="http://schemas.openxmlformats.org/drawingml/2006/main" r:embed="R677bd85b876d478a"/>
           <a:srcRect xmlns:a="http://schemas.openxmlformats.org/drawingml/2006/main" l="0" t="0" r="0" b="0"/>
           <a:stretch xmlns:a="http://schemas.openxmlformats.org/drawingml/2006/main"/>
         </p:blipFill>
@@ -10166,7 +10161,7 @@
                 <a:ea typeface="Arial Unicode MS"/>
                 <a:cs typeface="Arial Unicode MS"/>
               </a:rPr>
-              <a:t>每一轮都由 LLM 提议和复核，不是只参与开局</a:t>
+              <a:t>完整在线版每轮选择；最新 pilot 只保留第一轮</a:t>
             </a:r>
           </a:p>
         </p:txBody>
@@ -11633,7 +11628,7 @@
                 <a:ea typeface="Arial Unicode MS"/>
                 <a:cs typeface="Arial Unicode MS"/>
               </a:rPr>
-              <a:t>LLM 的真实权限</a:t>
+              <a:t>权限在实验中受限</a:t>
             </a:r>
           </a:p>
         </p:txBody>
@@ -11695,7 +11690,7 @@
                 <a:ea typeface="Arial Unicode MS"/>
                 <a:cs typeface="Arial Unicode MS"/>
               </a:rPr>
-              <a:t>10 / 10 轮都参与最终选择；可以改选非 rank 1 候选，也可以在证据不足时回退。</a:t>
+              <a:t>历史完整在线版：10 / 10；bounded pilot：1 / 10，后续交回 GP。首批 6 次均未 override GP rank 1。</a:t>
             </a:r>
           </a:p>
         </p:txBody>

</xml_diff>

<commit_message>
docs: explain heterogeneous LLM transfer gains
</commit_message>
<xml_diff>
--- a/CARE2.0_Nature_evidence_update_2026-08-24.pptx
+++ b/CARE2.0_Nature_evidence_update_2026-08-24.pptx
@@ -2,27 +2,27 @@
 <file path=ppt/presentation.xml><?xml version="1.0" encoding="utf-8"?>
 <p:presentation xmlns:p="http://schemas.openxmlformats.org/presentationml/2006/main">
   <p:sldMasterIdLst>
-    <p:sldMasterId xmlns:r="http://schemas.openxmlformats.org/officeDocument/2006/relationships" id="2147483648" r:id="R7b94c81234e84037"/>
+    <p:sldMasterId xmlns:r="http://schemas.openxmlformats.org/officeDocument/2006/relationships" id="2147483648" r:id="R965b50bd810e41e9"/>
   </p:sldMasterIdLst>
   <p:notesMasterIdLst>
-    <p:notesMasterId xmlns:r="http://schemas.openxmlformats.org/officeDocument/2006/relationships" r:id="R56d78e29f4314b94"/>
+    <p:notesMasterId xmlns:r="http://schemas.openxmlformats.org/officeDocument/2006/relationships" r:id="Rfc79cc0014984431"/>
   </p:notesMasterIdLst>
   <p:sldIdLst>
-    <p:sldId xmlns:r="http://schemas.openxmlformats.org/officeDocument/2006/relationships" id="256" r:id="R822cd5d5fa874190"/>
-    <p:sldId xmlns:r="http://schemas.openxmlformats.org/officeDocument/2006/relationships" id="257" r:id="R21d8a5f0df8940f7"/>
-    <p:sldId xmlns:r="http://schemas.openxmlformats.org/officeDocument/2006/relationships" id="258" r:id="Ra3b0814e74b44a81"/>
-    <p:sldId xmlns:r="http://schemas.openxmlformats.org/officeDocument/2006/relationships" id="259" r:id="R01b5825892c2431d"/>
-    <p:sldId xmlns:r="http://schemas.openxmlformats.org/officeDocument/2006/relationships" id="260" r:id="R7ecff02788fd4ae1"/>
-    <p:sldId xmlns:r="http://schemas.openxmlformats.org/officeDocument/2006/relationships" id="261" r:id="R4f24516b757c46bb"/>
-    <p:sldId xmlns:r="http://schemas.openxmlformats.org/officeDocument/2006/relationships" id="262" r:id="R9bd792387e40491c"/>
-    <p:sldId xmlns:r="http://schemas.openxmlformats.org/officeDocument/2006/relationships" id="263" r:id="R66e993be55544177"/>
-    <p:sldId xmlns:r="http://schemas.openxmlformats.org/officeDocument/2006/relationships" id="264" r:id="Rced3db1bace9411e"/>
-    <p:sldId xmlns:r="http://schemas.openxmlformats.org/officeDocument/2006/relationships" id="265" r:id="R79d29986ff1f40e6"/>
-    <p:sldId xmlns:r="http://schemas.openxmlformats.org/officeDocument/2006/relationships" id="266" r:id="R5b7c95514cf746d4"/>
-    <p:sldId xmlns:r="http://schemas.openxmlformats.org/officeDocument/2006/relationships" id="267" r:id="Ra64cbaed803e41ac"/>
-    <p:sldId xmlns:r="http://schemas.openxmlformats.org/officeDocument/2006/relationships" id="268" r:id="R7af949a1715142a8"/>
-    <p:sldId xmlns:r="http://schemas.openxmlformats.org/officeDocument/2006/relationships" id="269" r:id="Rd3c7e018e33b4f89"/>
-    <p:sldId xmlns:r="http://schemas.openxmlformats.org/officeDocument/2006/relationships" id="270" r:id="Rb06acd3b3b8b40ab"/>
+    <p:sldId xmlns:r="http://schemas.openxmlformats.org/officeDocument/2006/relationships" id="256" r:id="R10b43517cde74ac5"/>
+    <p:sldId xmlns:r="http://schemas.openxmlformats.org/officeDocument/2006/relationships" id="257" r:id="Re7c01254980246e5"/>
+    <p:sldId xmlns:r="http://schemas.openxmlformats.org/officeDocument/2006/relationships" id="258" r:id="R619595296e0c49a6"/>
+    <p:sldId xmlns:r="http://schemas.openxmlformats.org/officeDocument/2006/relationships" id="259" r:id="R22e09889822745c4"/>
+    <p:sldId xmlns:r="http://schemas.openxmlformats.org/officeDocument/2006/relationships" id="260" r:id="Rc3f9c739df0c4a79"/>
+    <p:sldId xmlns:r="http://schemas.openxmlformats.org/officeDocument/2006/relationships" id="261" r:id="R3162f215fe024a12"/>
+    <p:sldId xmlns:r="http://schemas.openxmlformats.org/officeDocument/2006/relationships" id="262" r:id="R8cf4e3a44d424aa8"/>
+    <p:sldId xmlns:r="http://schemas.openxmlformats.org/officeDocument/2006/relationships" id="263" r:id="R0a2cdde02e7347a3"/>
+    <p:sldId xmlns:r="http://schemas.openxmlformats.org/officeDocument/2006/relationships" id="264" r:id="R8ccb2a027ac344f1"/>
+    <p:sldId xmlns:r="http://schemas.openxmlformats.org/officeDocument/2006/relationships" id="265" r:id="R648b309a21b54cbe"/>
+    <p:sldId xmlns:r="http://schemas.openxmlformats.org/officeDocument/2006/relationships" id="266" r:id="R663c00ce916344a4"/>
+    <p:sldId xmlns:r="http://schemas.openxmlformats.org/officeDocument/2006/relationships" id="267" r:id="R47deffe29dd54e77"/>
+    <p:sldId xmlns:r="http://schemas.openxmlformats.org/officeDocument/2006/relationships" id="268" r:id="Rbbad0310e9134853"/>
+    <p:sldId xmlns:r="http://schemas.openxmlformats.org/officeDocument/2006/relationships" id="269" r:id="R7a2aecaa02034872"/>
+    <p:sldId xmlns:r="http://schemas.openxmlformats.org/officeDocument/2006/relationships" id="270" r:id="R2a49740e7591499a"/>
   </p:sldIdLst>
   <p:sldSz cx="12192000" cy="6858000"/>
   <p:notesSz cx="6858000" cy="9144000"/>
@@ -936,7 +936,7 @@
           </a:p>
           <a:p xmlns:a="http://schemas.openxmlformats.org/drawingml/2006/main">
             <a:r>
-              <a:t>这页重新排列证据层级：LLM 编译可执行 skill 是当前主贡献，在线候选选择仍是探索模块。</a:t>
+              <a:t>LLM 并不是在所有任务上都有效。现有消融表明，增益出现需要三个条件：语义表示与目标性质对齐，LLM 的输出实际改变实验动作，并且目标数据可以重新校准权重。</a:t>
             </a:r>
           </a:p>
           <a:p xmlns:a="http://schemas.openxmlformats.org/drawingml/2006/main">
@@ -951,7 +951,7 @@
           </a:p>
           <a:p xmlns:a="http://schemas.openxmlformats.org/drawingml/2006/main">
             <a:r>
-              <a:t>现有最扎实的 LLM 证据来自 frozen semantic-skill compiler。LLM 读取 source evidence 和 target public schema，生成规则特征、先验方向与 acquisition schedule；strict compiler 检查字段和值，calibration split 决定是否部署，held-out replay 不再调用 LLM。相对 strongest target-only anchor，FreeSolv、Buchwald-Hartwig 和 Matbench band gap 的 AUC 分别提高 +1.384、+2.859 和 +5.930。schedule-only 与 no-prior 同 seed 消融说明 semantic representation 和 prior direction 都有独立贡献；ChemLex 的负结果没有被提升为确认结论。相反，首批六条真实在线轨迹全部选择 GP rank 1，在线增量为 0。因此不能把“模型有回复”当作“模型改变了实验”。论文主线应聚焦 LLM 编译的可执行 skill，在线 proposer/critic 只作为仍待验证的假设修订与 abstention 模块。</a:t>
+              <a:t>第一类增益来自 representation。Matbench experimental band gap 中，LLM 提出的 high_element_count 分组相对 target portfolio 提高 AUC 6.167，95% 配对区间为 [4.361, 7.972]；Lipophilicity 中，high_aromatic_content 相对 GP-UCB 提高 AUC 1.261，区间为 [0.891, 1.630]。两项实验都没有向 LLM 提供 source outcomes，而且 no-prior 版本表现更好，说明 LLM 的贡献主要是选对语义特征，具体方向与强度仍应由目标数据和 GP 学习。</a:t>
             </a:r>
           </a:p>
           <a:p xmlns:a="http://schemas.openxmlformats.org/drawingml/2006/main">
@@ -961,22 +961,62 @@
           </a:p>
           <a:p xmlns:a="http://schemas.openxmlformats.org/drawingml/2006/main">
             <a:r>
+              <a:t>第二类增益来自 early coverage。机制消融中，ChemLex 到 Buchwald–Hartwig、dielectric 到 experimental band gap 的主要收益在 source-informed initial design。固定相同开局后，连续 source-outcome term 和 LLM patch 都没有额外增益。因此不能把这两条结果解释成 LLM 每轮自由重排更强，而应解释为 source knowledge 帮助系统更早覆盖了有价值的实验区域。</a:t>
+            </a:r>
+          </a:p>
+          <a:p xmlns:a="http://schemas.openxmlformats.org/drawingml/2006/main">
+            <a:r>
+              <a:t/>
+            </a:r>
+          </a:p>
+          <a:p xmlns:a="http://schemas.openxmlformats.org/drawingml/2006/main">
+            <a:r>
+              <a:t>第三，推理只有改变动作才可能产生因果增量。最新六条真实 bounded-authority pilot 全部选择 GP-UCB rank 1，在线 AUC 增量为 0。虽然三条 trace 文字上保留了 source hypothesis，但并未改变实验选择。相反，Lipophilicity 到 FreeSolv 的 matched transfer AUC 为 -29.902，表明共享分子描述符不足以保证目标方向可迁移。</a:t>
+            </a:r>
+          </a:p>
+          <a:p xmlns:a="http://schemas.openxmlformats.org/drawingml/2006/main">
+            <a:r>
+              <a:t/>
+            </a:r>
+          </a:p>
+          <a:p xmlns:a="http://schemas.openxmlformats.org/drawingml/2006/main">
+            <a:r>
+              <a:t>所以论文不声称“LLM 总能提高优化”。更准确的结论是：LLM 在语义表示对齐、能改变早期采样并允许目标数据重新校准时最可能有效；表示不匹配、目标符号不一致或动作与 GP 重合时，系统应该拒绝或回退。</a:t>
+            </a:r>
+          </a:p>
+          <a:p xmlns:a="http://schemas.openxmlformats.org/drawingml/2006/main">
+            <a:r>
+              <a:t/>
+            </a:r>
+          </a:p>
+          <a:p xmlns:a="http://schemas.openxmlformats.org/drawingml/2006/main">
+            <a:r>
               <a:t>[Sources]</a:t>
             </a:r>
           </a:p>
           <a:p xmlns:a="http://schemas.openxmlformats.org/drawingml/2006/main">
             <a:r>
-              <a:t>- docs/NATURE_SUBMISSION_READINESS.md</a:t>
-            </a:r>
-          </a:p>
-          <a:p xmlns:a="http://schemas.openxmlformats.org/drawingml/2006/main">
-            <a:r>
-              <a:t>- experiments/care_replay/results/2026-07-21-cross-domain-semantic-skills/README.md</a:t>
+              <a:t>- experiments/care_replay/results/2026-07-21-llm-evidence-causality/README.md</a:t>
+            </a:r>
+          </a:p>
+          <a:p xmlns:a="http://schemas.openxmlformats.org/drawingml/2006/main">
+            <a:r>
+              <a:t>- experiments/care_replay/results/2026-07-23-source-evidence-extension/README.md</a:t>
+            </a:r>
+          </a:p>
+          <a:p xmlns:a="http://schemas.openxmlformats.org/drawingml/2006/main">
+            <a:r>
+              <a:t>- experiments/care_replay/results/2026-08-07-mechanism-controls/README.md</a:t>
             </a:r>
           </a:p>
           <a:p xmlns:a="http://schemas.openxmlformats.org/drawingml/2006/main">
             <a:r>
               <a:t>- experiments/care_replay/results/2026-08-24-online-llm-bounded-authority-route-disjoint-confirmation-v1/pilot_audit/decision_impact_audit.json</a:t>
+            </a:r>
+          </a:p>
+          <a:p xmlns:a="http://schemas.openxmlformats.org/drawingml/2006/main">
+            <a:r>
+              <a:t>- docs/OVERLEAF_CASE_STUDIES_DRAFT.tex</a:t>
             </a:r>
           </a:p>
         </p:txBody>
@@ -2164,7 +2204,7 @@
   </p:cSld>
   <p:clrMap bg1="lt1" tx1="dk1" bg2="lt2" tx2="dk2" accent1="accent1" accent2="accent2" accent3="accent3" accent4="accent4" accent5="accent5" accent6="accent6" hlink="hlink" folHlink="folHlink"/>
   <p:sldLayoutIdLst>
-    <p:sldLayoutId xmlns:r="http://schemas.openxmlformats.org/officeDocument/2006/relationships" id="2147483649" r:id="R9292690611cd47ef"/>
+    <p:sldLayoutId xmlns:r="http://schemas.openxmlformats.org/officeDocument/2006/relationships" id="2147483649" r:id="R2b84081a008c4aca"/>
   </p:sldLayoutIdLst>
   <p:txStyles>
     <p:titleStyle>
@@ -3736,7 +3776,7 @@
           <p:nvPr/>
         </p:nvPicPr>
         <p:blipFill>
-          <a:blip xmlns:r="http://schemas.openxmlformats.org/officeDocument/2006/relationships" xmlns:a="http://schemas.openxmlformats.org/drawingml/2006/main" r:embed="R2a2e360ed2364957"/>
+          <a:blip xmlns:r="http://schemas.openxmlformats.org/officeDocument/2006/relationships" xmlns:a="http://schemas.openxmlformats.org/drawingml/2006/main" r:embed="R7eceb6c6ac094735"/>
           <a:stretch xmlns:a="http://schemas.openxmlformats.org/drawingml/2006/main"/>
         </p:blipFill>
         <p:spPr>
@@ -3820,7 +3860,7 @@
           <p:nvPr/>
         </p:nvPicPr>
         <p:blipFill>
-          <a:blip xmlns:r="http://schemas.openxmlformats.org/officeDocument/2006/relationships" xmlns:a="http://schemas.openxmlformats.org/drawingml/2006/main" r:embed="Rbb5c55b726cb4818"/>
+          <a:blip xmlns:r="http://schemas.openxmlformats.org/officeDocument/2006/relationships" xmlns:a="http://schemas.openxmlformats.org/drawingml/2006/main" r:embed="R067786cd73f6481a"/>
           <a:srcRect xmlns:a="http://schemas.openxmlformats.org/drawingml/2006/main" l="0" t="0" r="0" b="0"/>
           <a:stretch xmlns:a="http://schemas.openxmlformats.org/drawingml/2006/main"/>
         </p:blipFill>
@@ -4089,7 +4129,7 @@
           <p:nvPr/>
         </p:nvPicPr>
         <p:blipFill>
-          <a:blip xmlns:r="http://schemas.openxmlformats.org/officeDocument/2006/relationships" xmlns:a="http://schemas.openxmlformats.org/drawingml/2006/main" r:embed="R25551b6772f04c6e"/>
+          <a:blip xmlns:r="http://schemas.openxmlformats.org/officeDocument/2006/relationships" xmlns:a="http://schemas.openxmlformats.org/drawingml/2006/main" r:embed="R6d3936ac54024449"/>
           <a:stretch xmlns:a="http://schemas.openxmlformats.org/drawingml/2006/main"/>
         </p:blipFill>
         <p:spPr>
@@ -4173,7 +4213,7 @@
           <p:nvPr/>
         </p:nvPicPr>
         <p:blipFill>
-          <a:blip xmlns:r="http://schemas.openxmlformats.org/officeDocument/2006/relationships" xmlns:a="http://schemas.openxmlformats.org/drawingml/2006/main" r:embed="Rcaceb46f6af24abe"/>
+          <a:blip xmlns:r="http://schemas.openxmlformats.org/officeDocument/2006/relationships" xmlns:a="http://schemas.openxmlformats.org/drawingml/2006/main" r:embed="R7e5dc6bd9f624d53"/>
           <a:srcRect xmlns:a="http://schemas.openxmlformats.org/drawingml/2006/main" l="0" t="0" r="0" b="0"/>
           <a:stretch xmlns:a="http://schemas.openxmlformats.org/drawingml/2006/main"/>
         </p:blipFill>
@@ -4442,7 +4482,7 @@
           <p:nvPr/>
         </p:nvPicPr>
         <p:blipFill>
-          <a:blip xmlns:r="http://schemas.openxmlformats.org/officeDocument/2006/relationships" xmlns:a="http://schemas.openxmlformats.org/drawingml/2006/main" r:embed="R73f7bdb9b6bf4817"/>
+          <a:blip xmlns:r="http://schemas.openxmlformats.org/officeDocument/2006/relationships" xmlns:a="http://schemas.openxmlformats.org/drawingml/2006/main" r:embed="R6bdaf5a27d384779"/>
           <a:stretch xmlns:a="http://schemas.openxmlformats.org/drawingml/2006/main"/>
         </p:blipFill>
         <p:spPr>
@@ -4526,7 +4566,7 @@
           <p:nvPr/>
         </p:nvPicPr>
         <p:blipFill>
-          <a:blip xmlns:r="http://schemas.openxmlformats.org/officeDocument/2006/relationships" xmlns:a="http://schemas.openxmlformats.org/drawingml/2006/main" r:embed="R08ed687f58bd4e8e"/>
+          <a:blip xmlns:r="http://schemas.openxmlformats.org/officeDocument/2006/relationships" xmlns:a="http://schemas.openxmlformats.org/drawingml/2006/main" r:embed="Rfdce951216bb4b57"/>
           <a:srcRect xmlns:a="http://schemas.openxmlformats.org/drawingml/2006/main" l="0" t="12000" r="0" b="0"/>
           <a:stretch xmlns:a="http://schemas.openxmlformats.org/drawingml/2006/main"/>
         </p:blipFill>
@@ -4626,7 +4666,7 @@
                 <a:ea typeface="Arial Unicode MS"/>
                 <a:cs typeface="Arial Unicode MS"/>
               </a:rPr>
-              <a:t>现在能说什么</a:t>
+              <a:t>为什么有些 case 有增益</a:t>
             </a:r>
           </a:p>
         </p:txBody>
@@ -4750,7 +4790,7 @@
                 <a:ea typeface="Arial Unicode MS"/>
                 <a:cs typeface="Arial Unicode MS"/>
               </a:rPr>
-              <a:t>当前最强证据来自 LLM 生成的 skill，而不是在线选点</a:t>
+              <a:t>LLM 有效的前提：表示对齐，并真正改变实验动作</a:t>
             </a:r>
           </a:p>
         </p:txBody>
@@ -4843,7 +4883,7 @@
                 <a:ea typeface="Arial Unicode MS"/>
                 <a:cs typeface="Arial Unicode MS"/>
               </a:rPr>
-              <a:t>已经做到</a:t>
+              <a:t>什么时候有效</a:t>
             </a:r>
           </a:p>
         </p:txBody>
@@ -4936,7 +4976,7 @@
                 <a:ea typeface="Arial Unicode MS"/>
                 <a:cs typeface="Arial Unicode MS"/>
               </a:rPr>
-              <a:t>• LLM 编译 skill 已在 3 类真实任务获正向结果</a:t>
+              <a:t>• 语义特征与目标性质对齐</a:t>
             </a:r>
           </a:p>
           <a:p xmlns:a="http://schemas.openxmlformats.org/drawingml/2006/main">
@@ -4963,7 +5003,7 @@
                 <a:ea typeface="Arial Unicode MS"/>
                 <a:cs typeface="Arial Unicode MS"/>
               </a:rPr>
-              <a:t>• 500 held-out seeds：AUC +1.38 / +2.86 / +5.93</a:t>
+              <a:t>• Matbench 元素数分组：AUC +6.17</a:t>
             </a:r>
           </a:p>
           <a:p xmlns:a="http://schemas.openxmlformats.org/drawingml/2006/main">
@@ -4990,7 +5030,7 @@
                 <a:ea typeface="Arial Unicode MS"/>
                 <a:cs typeface="Arial Unicode MS"/>
               </a:rPr>
-              <a:t>• semantic rule 与 prior 消融均有贡献</a:t>
+              <a:t>• Lipophilicity 芳香性分组：AUC +1.26</a:t>
             </a:r>
           </a:p>
           <a:p xmlns:a="http://schemas.openxmlformats.org/drawingml/2006/main">
@@ -5017,7 +5057,7 @@
                 <a:ea typeface="Arial Unicode MS"/>
                 <a:cs typeface="Arial Unicode MS"/>
               </a:rPr>
-              <a:t>• ChemLex 负结果和全部 trace 保留</a:t>
+              <a:t>• 目标数据负责重新学习权重</a:t>
             </a:r>
           </a:p>
         </p:txBody>
@@ -5079,7 +5119,7 @@
                 <a:ea typeface="Arial Unicode MS"/>
                 <a:cs typeface="Arial Unicode MS"/>
               </a:rPr>
-              <a:t>还没有做到</a:t>
+              <a:t>增益来自哪里</a:t>
             </a:r>
           </a:p>
         </p:txBody>
@@ -5172,7 +5212,7 @@
                 <a:ea typeface="Arial Unicode MS"/>
                 <a:cs typeface="Arial Unicode MS"/>
               </a:rPr>
-              <a:t>• 在线 pilot：6 / 6 选择 GP rank 1</a:t>
+              <a:t>• source 主要改善初始实验覆盖</a:t>
             </a:r>
           </a:p>
           <a:p xmlns:a="http://schemas.openxmlformats.org/drawingml/2006/main">
@@ -5199,7 +5239,7 @@
                 <a:ea typeface="Arial Unicode MS"/>
                 <a:cs typeface="Arial Unicode MS"/>
               </a:rPr>
-              <a:t>• 在线 AUC 增量 0；override rate 0 / 6</a:t>
+              <a:t>• ChemLex → BH 开局收益最明显</a:t>
             </a:r>
           </a:p>
           <a:p xmlns:a="http://schemas.openxmlformats.org/drawingml/2006/main">
@@ -5226,7 +5266,7 @@
                 <a:ea typeface="Arial Unicode MS"/>
                 <a:cs typeface="Arial Unicode MS"/>
               </a:rPr>
-              <a:t>• 真正未参与开发的新任务家族</a:t>
+              <a:t>• 固定开局后，连续 source 增量为 0</a:t>
             </a:r>
           </a:p>
           <a:p xmlns:a="http://schemas.openxmlformats.org/drawingml/2006/main">
@@ -5253,7 +5293,7 @@
                 <a:ea typeface="Arial Unicode MS"/>
                 <a:cs typeface="Arial Unicode MS"/>
               </a:rPr>
-              <a:t>• source evidence 因果消融与前瞻 wet-lab</a:t>
+              <a:t>• LLM patch 也没有额外增益</a:t>
             </a:r>
           </a:p>
         </p:txBody>
@@ -5315,7 +5355,7 @@
                 <a:ea typeface="Arial Unicode MS"/>
                 <a:cs typeface="Arial Unicode MS"/>
               </a:rPr>
-              <a:t>系统边界</a:t>
+              <a:t>什么时候失效</a:t>
             </a:r>
           </a:p>
         </p:txBody>
@@ -5408,7 +5448,7 @@
                 <a:ea typeface="Arial Unicode MS"/>
                 <a:cs typeface="Arial Unicode MS"/>
               </a:rPr>
-              <a:t>• LLM 提出 skill，严格 compiler 执行</a:t>
+              <a:t>• 目标方向不一致：Lipo → FreeSolv -29.90</a:t>
             </a:r>
           </a:p>
           <a:p xmlns:a="http://schemas.openxmlformats.org/drawingml/2006/main">
@@ -5435,7 +5475,7 @@
                 <a:ea typeface="Arial Unicode MS"/>
                 <a:cs typeface="Arial Unicode MS"/>
               </a:rPr>
-              <a:t>• calibration 只使用开发 split</a:t>
+              <a:t>• 决策冗余：6 / 6 仍选 GP rank 1</a:t>
             </a:r>
           </a:p>
           <a:p xmlns:a="http://schemas.openxmlformats.org/drawingml/2006/main">
@@ -5462,7 +5502,7 @@
                 <a:ea typeface="Arial Unicode MS"/>
                 <a:cs typeface="Arial Unicode MS"/>
               </a:rPr>
-              <a:t>• 不训练 LLM 模型权重</a:t>
+              <a:t>• outcome summary 未优于 schema-only</a:t>
             </a:r>
           </a:p>
           <a:p xmlns:a="http://schemas.openxmlformats.org/drawingml/2006/main">
@@ -5489,7 +5529,7 @@
                 <a:ea typeface="Arial Unicode MS"/>
                 <a:cs typeface="Arial Unicode MS"/>
               </a:rPr>
-              <a:t>• 在线 proposer / critic 仍是探索模块</a:t>
+              <a:t>• 合理解释不等于性能证据</a:t>
             </a:r>
           </a:p>
         </p:txBody>
@@ -5582,7 +5622,7 @@
                 <a:ea typeface="Arial Unicode MS"/>
                 <a:cs typeface="Arial Unicode MS"/>
               </a:rPr>
-              <a:t>一句话：主线应是“LLM 把经验编译成可执行 skill，再由校准与 GP 安全执行”；</a:t>
+              <a:t>判断标准：semantic alignment + action change + target recalibration；</a:t>
             </a:r>
           </a:p>
           <a:p xmlns:a="http://schemas.openxmlformats.org/drawingml/2006/main">
@@ -5609,7 +5649,7 @@
                 <a:ea typeface="Arial Unicode MS"/>
                 <a:cs typeface="Arial Unicode MS"/>
               </a:rPr>
-              <a:t>在线 LLM 有完整 trace，但还没有证明会改善决策。</a:t>
+              <a:t>缺少其中一项，迁移通常持平或转负。</a:t>
             </a:r>
           </a:p>
         </p:txBody>
@@ -7324,7 +7364,7 @@
           <p:nvPr/>
         </p:nvPicPr>
         <p:blipFill>
-          <a:blip xmlns:r="http://schemas.openxmlformats.org/officeDocument/2006/relationships" xmlns:a="http://schemas.openxmlformats.org/drawingml/2006/main" r:embed="R36786a35ddac453a"/>
+          <a:blip xmlns:r="http://schemas.openxmlformats.org/officeDocument/2006/relationships" xmlns:a="http://schemas.openxmlformats.org/drawingml/2006/main" r:embed="Ra09c94facd8c44eb"/>
           <a:stretch xmlns:a="http://schemas.openxmlformats.org/drawingml/2006/main"/>
         </p:blipFill>
         <p:spPr>
@@ -7408,7 +7448,7 @@
           <p:nvPr/>
         </p:nvPicPr>
         <p:blipFill>
-          <a:blip xmlns:r="http://schemas.openxmlformats.org/officeDocument/2006/relationships" xmlns:a="http://schemas.openxmlformats.org/drawingml/2006/main" r:embed="R677bd85b876d478a"/>
+          <a:blip xmlns:r="http://schemas.openxmlformats.org/officeDocument/2006/relationships" xmlns:a="http://schemas.openxmlformats.org/drawingml/2006/main" r:embed="R4dd583d997f04e1a"/>
           <a:srcRect xmlns:a="http://schemas.openxmlformats.org/drawingml/2006/main" l="0" t="0" r="0" b="0"/>
           <a:stretch xmlns:a="http://schemas.openxmlformats.org/drawingml/2006/main"/>
         </p:blipFill>

</xml_diff>

<commit_message>
experiments: publish source outcome falsification evidence
</commit_message>
<xml_diff>
--- a/CARE2.0_Nature_evidence_update_2026-08-24.pptx
+++ b/CARE2.0_Nature_evidence_update_2026-08-24.pptx
@@ -2,27 +2,27 @@
 <file path=ppt/presentation.xml><?xml version="1.0" encoding="utf-8"?>
 <p:presentation xmlns:p="http://schemas.openxmlformats.org/presentationml/2006/main">
   <p:sldMasterIdLst>
-    <p:sldMasterId xmlns:r="http://schemas.openxmlformats.org/officeDocument/2006/relationships" id="2147483648" r:id="R965b50bd810e41e9"/>
+    <p:sldMasterId xmlns:r="http://schemas.openxmlformats.org/officeDocument/2006/relationships" id="2147483648" r:id="R5e89bafe34cb46cf"/>
   </p:sldMasterIdLst>
   <p:notesMasterIdLst>
-    <p:notesMasterId xmlns:r="http://schemas.openxmlformats.org/officeDocument/2006/relationships" r:id="Rfc79cc0014984431"/>
+    <p:notesMasterId xmlns:r="http://schemas.openxmlformats.org/officeDocument/2006/relationships" r:id="Rac231b282b444fea"/>
   </p:notesMasterIdLst>
   <p:sldIdLst>
-    <p:sldId xmlns:r="http://schemas.openxmlformats.org/officeDocument/2006/relationships" id="256" r:id="R10b43517cde74ac5"/>
-    <p:sldId xmlns:r="http://schemas.openxmlformats.org/officeDocument/2006/relationships" id="257" r:id="Re7c01254980246e5"/>
-    <p:sldId xmlns:r="http://schemas.openxmlformats.org/officeDocument/2006/relationships" id="258" r:id="R619595296e0c49a6"/>
-    <p:sldId xmlns:r="http://schemas.openxmlformats.org/officeDocument/2006/relationships" id="259" r:id="R22e09889822745c4"/>
-    <p:sldId xmlns:r="http://schemas.openxmlformats.org/officeDocument/2006/relationships" id="260" r:id="Rc3f9c739df0c4a79"/>
-    <p:sldId xmlns:r="http://schemas.openxmlformats.org/officeDocument/2006/relationships" id="261" r:id="R3162f215fe024a12"/>
-    <p:sldId xmlns:r="http://schemas.openxmlformats.org/officeDocument/2006/relationships" id="262" r:id="R8cf4e3a44d424aa8"/>
-    <p:sldId xmlns:r="http://schemas.openxmlformats.org/officeDocument/2006/relationships" id="263" r:id="R0a2cdde02e7347a3"/>
-    <p:sldId xmlns:r="http://schemas.openxmlformats.org/officeDocument/2006/relationships" id="264" r:id="R8ccb2a027ac344f1"/>
-    <p:sldId xmlns:r="http://schemas.openxmlformats.org/officeDocument/2006/relationships" id="265" r:id="R648b309a21b54cbe"/>
-    <p:sldId xmlns:r="http://schemas.openxmlformats.org/officeDocument/2006/relationships" id="266" r:id="R663c00ce916344a4"/>
-    <p:sldId xmlns:r="http://schemas.openxmlformats.org/officeDocument/2006/relationships" id="267" r:id="R47deffe29dd54e77"/>
-    <p:sldId xmlns:r="http://schemas.openxmlformats.org/officeDocument/2006/relationships" id="268" r:id="Rbbad0310e9134853"/>
-    <p:sldId xmlns:r="http://schemas.openxmlformats.org/officeDocument/2006/relationships" id="269" r:id="R7a2aecaa02034872"/>
-    <p:sldId xmlns:r="http://schemas.openxmlformats.org/officeDocument/2006/relationships" id="270" r:id="R2a49740e7591499a"/>
+    <p:sldId xmlns:r="http://schemas.openxmlformats.org/officeDocument/2006/relationships" id="256" r:id="R8bbcfc39d4044078"/>
+    <p:sldId xmlns:r="http://schemas.openxmlformats.org/officeDocument/2006/relationships" id="257" r:id="Rf7d454d29dea4191"/>
+    <p:sldId xmlns:r="http://schemas.openxmlformats.org/officeDocument/2006/relationships" id="258" r:id="R081aba56997a48b7"/>
+    <p:sldId xmlns:r="http://schemas.openxmlformats.org/officeDocument/2006/relationships" id="259" r:id="R72fdfb9076a34ab5"/>
+    <p:sldId xmlns:r="http://schemas.openxmlformats.org/officeDocument/2006/relationships" id="260" r:id="Rde2ea746bba74a76"/>
+    <p:sldId xmlns:r="http://schemas.openxmlformats.org/officeDocument/2006/relationships" id="261" r:id="Rb598bccd8bb34448"/>
+    <p:sldId xmlns:r="http://schemas.openxmlformats.org/officeDocument/2006/relationships" id="262" r:id="R06890e2cf98e4b6b"/>
+    <p:sldId xmlns:r="http://schemas.openxmlformats.org/officeDocument/2006/relationships" id="263" r:id="R422125a5407b4f96"/>
+    <p:sldId xmlns:r="http://schemas.openxmlformats.org/officeDocument/2006/relationships" id="264" r:id="R6f0f0deb8c5c4bcd"/>
+    <p:sldId xmlns:r="http://schemas.openxmlformats.org/officeDocument/2006/relationships" id="265" r:id="R619a512afb374d39"/>
+    <p:sldId xmlns:r="http://schemas.openxmlformats.org/officeDocument/2006/relationships" id="266" r:id="R7a6371f15b19406f"/>
+    <p:sldId xmlns:r="http://schemas.openxmlformats.org/officeDocument/2006/relationships" id="267" r:id="R8afaee00027742e7"/>
+    <p:sldId xmlns:r="http://schemas.openxmlformats.org/officeDocument/2006/relationships" id="268" r:id="Re1900d1b2fea4cdc"/>
+    <p:sldId xmlns:r="http://schemas.openxmlformats.org/officeDocument/2006/relationships" id="269" r:id="R080d183e982345e8"/>
+    <p:sldId xmlns:r="http://schemas.openxmlformats.org/officeDocument/2006/relationships" id="270" r:id="Rcf68790b992a4978"/>
   </p:sldIdLst>
   <p:sldSz cx="12192000" cy="6858000"/>
   <p:notesSz cx="6858000" cy="9144000"/>
@@ -1091,7 +1091,7 @@
           </a:p>
           <a:p xmlns:a="http://schemas.openxmlformats.org/drawingml/2006/main">
             <a:r>
-              <a:t>下一步不是继续堆在线调用，而是先证明 LLM 的输出确实改变动作，并把 semantic skill 放到新任务上做冻结验证。</a:t>
+              <a:t>这项检验把两个容易混在一起的问题拆开：source-informed 开局是否优于 target-only，以及“正确的 source 特征—outcome 对应关系”是否真的提供额外信息。</a:t>
             </a:r>
           </a:p>
           <a:p xmlns:a="http://schemas.openxmlformats.org/drawingml/2006/main">
@@ -1106,7 +1106,7 @@
           </a:p>
           <a:p xmlns:a="http://schemas.openxmlformats.org/drawingml/2006/main">
             <a:r>
-              <a:t>在线 pilot 的 6 个成功调用共消耗 99,243 tokens，但 6 次都选择 GP rank 1，说明直接扩成 180 次只会高成本重复无决策影响的策略。该启动还保留了一次 inactive-key 的 pre-response 失败，按冻结 retry semantics 已经无法满足原来的完整确认条件。下一步先只在 development routes 上开发 challenger 或 semantic skill policy，要求出现非零且有益的 action change；随后在新任务上冻结 skill、compiler、数据 split、baseline 和统计口径，再开始 disjoint evaluation。与此同时必须补 RGPE、multitask GP 等同预算强 baseline、source evidence / semantic rule / prior / critic 的同 seed 消融，以及至少一条 prospective wet-lab campaign。</a:t>
+              <a:t>实验冻结了三条路线。每条路线使用 100 个 held-out target seeds 和 19 个 source-outcome 置换；source features、LLM 编译的 role map 与 patches、target 初始化规则、优化器和预算全部保持一致，只打乱 measured source outcomes 与 source candidates 的对应关系。sequential transfer mass 固定为 0，因此这里检验的是 source-informed initial design，而不是后续连续迁移。</a:t>
             </a:r>
           </a:p>
           <a:p xmlns:a="http://schemas.openxmlformats.org/drawingml/2006/main">
@@ -1116,22 +1116,57 @@
           </a:p>
           <a:p xmlns:a="http://schemas.openxmlformats.org/drawingml/2006/main">
             <a:r>
+              <a:t>左图回答“真实 source outcomes 相比 target-only 是否改善有限预算搜索”。ChemLex 到 Buchwald–Hartwig 的 AUC 提升 +9.672，95% CI 为 [+7.405, +11.939]；dielectric 到 experimental gap 提升 +48.954，区间为 [+44.050, +53.857]；Lipophilicity 到 FreeSolv 为 -1.027，区间为 [-1.228, -0.826]。所以 reaction 和 materials 的 source-informed starts 确实更早找到好候选，但 molecular 路线仍有负迁移。</a:t>
+            </a:r>
+          </a:p>
+          <a:p xmlns:a="http://schemas.openxmlformats.org/drawingml/2006/main">
+            <a:r>
+              <a:t/>
+            </a:r>
+          </a:p>
+          <a:p xmlns:a="http://schemas.openxmlformats.org/drawingml/2006/main">
+            <a:r>
+              <a:t>右图回答更严格的问题：正确 outcome 绑定是否优于随机绑定。真实绑定相对 19 个置换均值分别为 +20.347、+47.766 和 +0.451，但 one-sided empirical p 值是 0.15、0.10 和 0.20，均未达到 0.05。这里不能因为 paired-seed CI 在零以上就说随机化检验显著：CI 衡量固定置换集合下跨 target seeds 的稳定性，p 值衡量正确绑定在 outcome-assignment null 中是否足够极端，后者才对应因果问题。</a:t>
+            </a:r>
+          </a:p>
+          <a:p xmlns:a="http://schemas.openxmlformats.org/drawingml/2006/main">
+            <a:r>
+              <a:t/>
+            </a:r>
+          </a:p>
+          <a:p xmlns:a="http://schemas.openxmlformats.org/drawingml/2006/main">
+            <a:r>
+              <a:t>因此，这一页支持“source-informed initial design 在两条路线有效”，不支持“正确 source feature–outcome association 已被验证”。论文应把 source-outcome learning 降为待确认机制，把 LLM-compiled semantic skill、可执行 compiler、falsification 和安全拒绝作为更稳的主贡献。下一步应在新路线和前瞻任务上预先冻结相同检验，而不是继续从这三条已知路线调规则。</a:t>
+            </a:r>
+          </a:p>
+          <a:p xmlns:a="http://schemas.openxmlformats.org/drawingml/2006/main">
+            <a:r>
+              <a:t/>
+            </a:r>
+          </a:p>
+          <a:p xmlns:a="http://schemas.openxmlformats.org/drawingml/2006/main">
+            <a:r>
               <a:t>[Sources]</a:t>
             </a:r>
           </a:p>
           <a:p xmlns:a="http://schemas.openxmlformats.org/drawingml/2006/main">
             <a:r>
-              <a:t>- docs/NATURE_SUBMISSION_READINESS.md</a:t>
-            </a:r>
-          </a:p>
-          <a:p xmlns:a="http://schemas.openxmlformats.org/drawingml/2006/main">
-            <a:r>
-              <a:t>- experiments/care_replay/results/2026-08-24-online-llm-bounded-authority-route-disjoint-confirmation-v1/pilot_audit/PILOT_RESULTS.md</a:t>
-            </a:r>
-          </a:p>
-          <a:p xmlns:a="http://schemas.openxmlformats.org/drawingml/2006/main">
-            <a:r>
-              <a:t>- experiments/care_replay/results/2026-07-21-cross-domain-semantic-skills/README.md</a:t>
+              <a:t>- experiments/care_replay/configs/source_outcome_falsification_v1.json</a:t>
+            </a:r>
+          </a:p>
+          <a:p xmlns:a="http://schemas.openxmlformats.org/drawingml/2006/main">
+            <a:r>
+              <a:t>- experiments/care_replay/results/2026-08-24-source-outcome-falsification-v1/falsification_report.json</a:t>
+            </a:r>
+          </a:p>
+          <a:p xmlns:a="http://schemas.openxmlformats.org/drawingml/2006/main">
+            <a:r>
+              <a:t>- experiments/care_replay/results/2026-08-24-source-outcome-falsification-v1/trajectory_metrics.csv</a:t>
+            </a:r>
+          </a:p>
+          <a:p xmlns:a="http://schemas.openxmlformats.org/drawingml/2006/main">
+            <a:r>
+              <a:t>- experiments/care_replay/scripts/plot_source_outcome_falsification.py</a:t>
             </a:r>
           </a:p>
         </p:txBody>
@@ -2204,7 +2239,7 @@
   </p:cSld>
   <p:clrMap bg1="lt1" tx1="dk1" bg2="lt2" tx2="dk2" accent1="accent1" accent2="accent2" accent3="accent3" accent4="accent4" accent5="accent5" accent6="accent6" hlink="hlink" folHlink="folHlink"/>
   <p:sldLayoutIdLst>
-    <p:sldLayoutId xmlns:r="http://schemas.openxmlformats.org/officeDocument/2006/relationships" id="2147483649" r:id="R2b84081a008c4aca"/>
+    <p:sldLayoutId xmlns:r="http://schemas.openxmlformats.org/officeDocument/2006/relationships" id="2147483649" r:id="Rafbee299bcbe4869"/>
   </p:sldLayoutIdLst>
   <p:txStyles>
     <p:titleStyle>
@@ -3776,7 +3811,7 @@
           <p:nvPr/>
         </p:nvPicPr>
         <p:blipFill>
-          <a:blip xmlns:r="http://schemas.openxmlformats.org/officeDocument/2006/relationships" xmlns:a="http://schemas.openxmlformats.org/drawingml/2006/main" r:embed="R7eceb6c6ac094735"/>
+          <a:blip xmlns:r="http://schemas.openxmlformats.org/officeDocument/2006/relationships" xmlns:a="http://schemas.openxmlformats.org/drawingml/2006/main" r:embed="R43f4d6dbdd3c41c1"/>
           <a:stretch xmlns:a="http://schemas.openxmlformats.org/drawingml/2006/main"/>
         </p:blipFill>
         <p:spPr>
@@ -3860,7 +3895,7 @@
           <p:nvPr/>
         </p:nvPicPr>
         <p:blipFill>
-          <a:blip xmlns:r="http://schemas.openxmlformats.org/officeDocument/2006/relationships" xmlns:a="http://schemas.openxmlformats.org/drawingml/2006/main" r:embed="R067786cd73f6481a"/>
+          <a:blip xmlns:r="http://schemas.openxmlformats.org/officeDocument/2006/relationships" xmlns:a="http://schemas.openxmlformats.org/drawingml/2006/main" r:embed="Rcbfbef0c5dfc4aa4"/>
           <a:srcRect xmlns:a="http://schemas.openxmlformats.org/drawingml/2006/main" l="0" t="0" r="0" b="0"/>
           <a:stretch xmlns:a="http://schemas.openxmlformats.org/drawingml/2006/main"/>
         </p:blipFill>
@@ -4129,7 +4164,7 @@
           <p:nvPr/>
         </p:nvPicPr>
         <p:blipFill>
-          <a:blip xmlns:r="http://schemas.openxmlformats.org/officeDocument/2006/relationships" xmlns:a="http://schemas.openxmlformats.org/drawingml/2006/main" r:embed="R6d3936ac54024449"/>
+          <a:blip xmlns:r="http://schemas.openxmlformats.org/officeDocument/2006/relationships" xmlns:a="http://schemas.openxmlformats.org/drawingml/2006/main" r:embed="Rd22b087722894200"/>
           <a:stretch xmlns:a="http://schemas.openxmlformats.org/drawingml/2006/main"/>
         </p:blipFill>
         <p:spPr>
@@ -4213,7 +4248,7 @@
           <p:nvPr/>
         </p:nvPicPr>
         <p:blipFill>
-          <a:blip xmlns:r="http://schemas.openxmlformats.org/officeDocument/2006/relationships" xmlns:a="http://schemas.openxmlformats.org/drawingml/2006/main" r:embed="R7e5dc6bd9f624d53"/>
+          <a:blip xmlns:r="http://schemas.openxmlformats.org/officeDocument/2006/relationships" xmlns:a="http://schemas.openxmlformats.org/drawingml/2006/main" r:embed="Radca84bfed994180"/>
           <a:srcRect xmlns:a="http://schemas.openxmlformats.org/drawingml/2006/main" l="0" t="0" r="0" b="0"/>
           <a:stretch xmlns:a="http://schemas.openxmlformats.org/drawingml/2006/main"/>
         </p:blipFill>
@@ -4482,7 +4517,7 @@
           <p:nvPr/>
         </p:nvPicPr>
         <p:blipFill>
-          <a:blip xmlns:r="http://schemas.openxmlformats.org/officeDocument/2006/relationships" xmlns:a="http://schemas.openxmlformats.org/drawingml/2006/main" r:embed="R6bdaf5a27d384779"/>
+          <a:blip xmlns:r="http://schemas.openxmlformats.org/officeDocument/2006/relationships" xmlns:a="http://schemas.openxmlformats.org/drawingml/2006/main" r:embed="R3d94ff59a4814dd5"/>
           <a:stretch xmlns:a="http://schemas.openxmlformats.org/drawingml/2006/main"/>
         </p:blipFill>
         <p:spPr>
@@ -4566,7 +4601,7 @@
           <p:nvPr/>
         </p:nvPicPr>
         <p:blipFill>
-          <a:blip xmlns:r="http://schemas.openxmlformats.org/officeDocument/2006/relationships" xmlns:a="http://schemas.openxmlformats.org/drawingml/2006/main" r:embed="Rfdce951216bb4b57"/>
+          <a:blip xmlns:r="http://schemas.openxmlformats.org/officeDocument/2006/relationships" xmlns:a="http://schemas.openxmlformats.org/drawingml/2006/main" r:embed="R894e94a571f344e6"/>
           <a:srcRect xmlns:a="http://schemas.openxmlformats.org/drawingml/2006/main" l="0" t="12000" r="0" b="0"/>
           <a:stretch xmlns:a="http://schemas.openxmlformats.org/drawingml/2006/main"/>
         </p:blipFill>
@@ -5747,10 +5782,10 @@
       </p:grpSpPr>
       <p:sp>
         <p:nvSpPr>
-          <p:cNvPr id="26" name="">
-            <a:extLst xmlns:a="http://schemas.openxmlformats.org/drawingml/2006/main">
-              <a:ext uri="{FF2B5EF4-FFF2-40B4-BE49-F238E27FC236}">
-                <a16:creationId xmlns:a16="http://schemas.microsoft.com/office/drawing/2014/main" id="{CF7F2D13-8B4E-4B7B-942E-F0FA2569EDC5}"/>
+          <p:cNvPr id="7" name="">
+            <a:extLst xmlns:a="http://schemas.openxmlformats.org/drawingml/2006/main">
+              <a:ext uri="{FF2B5EF4-FFF2-40B4-BE49-F238E27FC236}">
+                <a16:creationId xmlns:a16="http://schemas.microsoft.com/office/drawing/2014/main" id="{6C311705-E0EB-402F-B1A7-C288385A231C}"/>
               </a:ext>
             </a:extLst>
           </p:cNvPr>
@@ -5802,7 +5837,7 @@
                 <a:ea typeface="Arial Unicode MS"/>
                 <a:cs typeface="Arial Unicode MS"/>
               </a:rPr>
-              <a:t>下一步</a:t>
+              <a:t>Source-outcome 因果检验</a:t>
             </a:r>
           </a:p>
         </p:txBody>
@@ -5812,7 +5847,7 @@
           <p:cNvPr id="2" name="">
             <a:extLst xmlns:a="http://schemas.openxmlformats.org/drawingml/2006/main">
               <a:ext uri="{FF2B5EF4-FFF2-40B4-BE49-F238E27FC236}">
-                <a16:creationId xmlns:a16="http://schemas.microsoft.com/office/drawing/2014/main" id="{FB1C6B19-68E6-44C5-A6F5-4D3CDD25A058}"/>
+                <a16:creationId xmlns:a16="http://schemas.microsoft.com/office/drawing/2014/main" id="{1543A56E-44FC-448E-B95A-42B22110256A}"/>
               </a:ext>
             </a:extLst>
           </p:cNvPr>
@@ -5874,7 +5909,7 @@
           <p:cNvPr id="3" name="">
             <a:extLst xmlns:a="http://schemas.openxmlformats.org/drawingml/2006/main">
               <a:ext uri="{FF2B5EF4-FFF2-40B4-BE49-F238E27FC236}">
-                <a16:creationId xmlns:a16="http://schemas.microsoft.com/office/drawing/2014/main" id="{630DFCA5-FB0C-4D8C-BF5E-A41CE4647145}"/>
+                <a16:creationId xmlns:a16="http://schemas.microsoft.com/office/drawing/2014/main" id="{91589F62-8A06-48D2-A906-6E23C1D2A667}"/>
               </a:ext>
             </a:extLst>
           </p:cNvPr>
@@ -5908,25 +5943,25 @@
                 <a:spcPct val="96000"/>
               </a:lnSpc>
               <a:buNone/>
-              <a:defRPr sz="2550" b="1">
-                <a:solidFill>
-                  <a:srgbClr val="17232E"/>
-                </a:solidFill>
-                <a:latin typeface="Arial Unicode MS"/>
-                <a:ea typeface="Arial Unicode MS"/>
-                <a:cs typeface="Arial Unicode MS"/>
-              </a:defRPr>
-            </a:pPr>
-            <a:r>
-              <a:rPr sz="2550" b="1">
-                <a:solidFill>
-                  <a:srgbClr val="17232E"/>
-                </a:solidFill>
-                <a:latin typeface="Arial Unicode MS"/>
-                <a:ea typeface="Arial Unicode MS"/>
-                <a:cs typeface="Arial Unicode MS"/>
-              </a:rPr>
-              <a:t>先证明 LLM 改变了决策，再做大规模重复</a:t>
+              <a:defRPr sz="2475" b="1">
+                <a:solidFill>
+                  <a:srgbClr val="17232E"/>
+                </a:solidFill>
+                <a:latin typeface="Arial Unicode MS"/>
+                <a:ea typeface="Arial Unicode MS"/>
+                <a:cs typeface="Arial Unicode MS"/>
+              </a:defRPr>
+            </a:pPr>
+            <a:r>
+              <a:rPr sz="2475" b="1">
+                <a:solidFill>
+                  <a:srgbClr val="17232E"/>
+                </a:solidFill>
+                <a:latin typeface="Arial Unicode MS"/>
+                <a:ea typeface="Arial Unicode MS"/>
+                <a:cs typeface="Arial Unicode MS"/>
+              </a:rPr>
+              <a:t>两条路线优于 target-only，但正确 outcome 绑定未通过置换检验</a:t>
             </a:r>
           </a:p>
         </p:txBody>
@@ -5936,7 +5971,7 @@
           <p:cNvPr id="4" name="">
             <a:extLst xmlns:a="http://schemas.openxmlformats.org/drawingml/2006/main">
               <a:ext uri="{FF2B5EF4-FFF2-40B4-BE49-F238E27FC236}">
-                <a16:creationId xmlns:a16="http://schemas.microsoft.com/office/drawing/2014/main" id="{FA4400FA-5A0E-4659-B4E5-4C74DFCCB429}"/>
+                <a16:creationId xmlns:a16="http://schemas.microsoft.com/office/drawing/2014/main" id="{77ECEF1D-351C-443E-8CF8-6F33B746330A}"/>
               </a:ext>
             </a:extLst>
           </p:cNvPr>
@@ -5964,22 +5999,22 @@
       </p:sp>
       <p:sp>
         <p:nvSpPr>
-          <p:cNvPr id="5" name="">
-            <a:extLst xmlns:a="http://schemas.openxmlformats.org/drawingml/2006/main">
-              <a:ext uri="{FF2B5EF4-FFF2-40B4-BE49-F238E27FC236}">
-                <a16:creationId xmlns:a16="http://schemas.microsoft.com/office/drawing/2014/main" id="{40D7FD66-9A24-4FB5-87EB-78C973CCDABA}"/>
-              </a:ext>
-            </a:extLst>
-          </p:cNvPr>
-          <p:cNvSpPr>
-            <a:spLocks xmlns:a="http://schemas.openxmlformats.org/drawingml/2006/main" noGrp="1"/>
-          </p:cNvSpPr>
-          <p:nvPr/>
-        </p:nvSpPr>
-        <p:spPr>
-          <a:xfrm xmlns:a="http://schemas.openxmlformats.org/drawingml/2006/main">
-            <a:off x="647700" y="1562100"/>
-            <a:ext cx="533400" cy="266700"/>
+          <p:cNvPr id="6" name="">
+            <a:extLst xmlns:a="http://schemas.openxmlformats.org/drawingml/2006/main">
+              <a:ext uri="{FF2B5EF4-FFF2-40B4-BE49-F238E27FC236}">
+                <a16:creationId xmlns:a16="http://schemas.microsoft.com/office/drawing/2014/main" id="{D1B4F285-B5EF-4E37-9F30-02CAC87F6E8F}"/>
+              </a:ext>
+            </a:extLst>
+          </p:cNvPr>
+          <p:cNvSpPr>
+            <a:spLocks xmlns:a="http://schemas.openxmlformats.org/drawingml/2006/main" noGrp="1"/>
+          </p:cNvSpPr>
+          <p:nvPr/>
+        </p:nvSpPr>
+        <p:spPr>
+          <a:xfrm xmlns:a="http://schemas.openxmlformats.org/drawingml/2006/main">
+            <a:off x="647700" y="6600825"/>
+            <a:ext cx="10896600" cy="133350"/>
           </a:xfrm>
           <a:prstGeom xmlns:a="http://schemas.openxmlformats.org/drawingml/2006/main" prst="rect">
             <a:avLst/>
@@ -5996,1096 +6031,11 @@
           </a:bodyPr>
           <a:lstStyle xmlns:a="http://schemas.openxmlformats.org/drawingml/2006/main"/>
           <a:p xmlns:a="http://schemas.openxmlformats.org/drawingml/2006/main">
-            <a:pPr algn="l">
+            <a:pPr algn="r">
               <a:lnSpc>
                 <a:spcPct val="106000"/>
               </a:lnSpc>
               <a:buNone/>
-              <a:defRPr sz="1350" b="1">
-                <a:solidFill>
-                  <a:srgbClr val="C94D4D"/>
-                </a:solidFill>
-                <a:latin typeface="Arial Unicode MS"/>
-                <a:ea typeface="Arial Unicode MS"/>
-                <a:cs typeface="Arial Unicode MS"/>
-              </a:defRPr>
-            </a:pPr>
-            <a:r>
-              <a:rPr sz="1350" b="1">
-                <a:solidFill>
-                  <a:srgbClr val="C94D4D"/>
-                </a:solidFill>
-                <a:latin typeface="Arial Unicode MS"/>
-                <a:ea typeface="Arial Unicode MS"/>
-                <a:cs typeface="Arial Unicode MS"/>
-              </a:rPr>
-              <a:t>P0</a:t>
-            </a:r>
-          </a:p>
-        </p:txBody>
-      </p:sp>
-      <p:sp>
-        <p:nvSpPr>
-          <p:cNvPr id="6" name="">
-            <a:extLst xmlns:a="http://schemas.openxmlformats.org/drawingml/2006/main">
-              <a:ext uri="{FF2B5EF4-FFF2-40B4-BE49-F238E27FC236}">
-                <a16:creationId xmlns:a16="http://schemas.microsoft.com/office/drawing/2014/main" id="{29578B60-C303-4A01-91CE-F4D4DCA96FB2}"/>
-              </a:ext>
-            </a:extLst>
-          </p:cNvPr>
-          <p:cNvSpPr>
-            <a:spLocks xmlns:a="http://schemas.openxmlformats.org/drawingml/2006/main" noGrp="1"/>
-          </p:cNvSpPr>
-          <p:nvPr/>
-        </p:nvSpPr>
-        <p:spPr>
-          <a:xfrm xmlns:a="http://schemas.openxmlformats.org/drawingml/2006/main">
-            <a:off x="1371600" y="1543050"/>
-            <a:ext cx="3238500" cy="323850"/>
-          </a:xfrm>
-          <a:prstGeom xmlns:a="http://schemas.openxmlformats.org/drawingml/2006/main" prst="rect">
-            <a:avLst/>
-          </a:prstGeom>
-          <a:noFill xmlns:a="http://schemas.openxmlformats.org/drawingml/2006/main"/>
-          <a:ln xmlns:a="http://schemas.openxmlformats.org/drawingml/2006/main" w="0">
-            <a:noFill/>
-            <a:prstDash val="solid"/>
-          </a:ln>
-        </p:spPr>
-        <p:txBody>
-          <a:bodyPr xmlns:a="http://schemas.openxmlformats.org/drawingml/2006/main" wrap="square" lIns="0" tIns="0" rIns="0" bIns="0" anchor="t">
-            <a:normAutofit fontScale="100000"/>
-          </a:bodyPr>
-          <a:lstStyle xmlns:a="http://schemas.openxmlformats.org/drawingml/2006/main"/>
-          <a:p xmlns:a="http://schemas.openxmlformats.org/drawingml/2006/main">
-            <a:pPr algn="l">
-              <a:lnSpc>
-                <a:spcPct val="106000"/>
-              </a:lnSpc>
-              <a:buNone/>
-              <a:defRPr sz="1725" b="1">
-                <a:solidFill>
-                  <a:srgbClr val="17232E"/>
-                </a:solidFill>
-                <a:latin typeface="Arial Unicode MS"/>
-                <a:ea typeface="Arial Unicode MS"/>
-                <a:cs typeface="Arial Unicode MS"/>
-              </a:defRPr>
-            </a:pPr>
-            <a:r>
-              <a:rPr sz="1725" b="1">
-                <a:solidFill>
-                  <a:srgbClr val="17232E"/>
-                </a:solidFill>
-                <a:latin typeface="Arial Unicode MS"/>
-                <a:ea typeface="Arial Unicode MS"/>
-                <a:cs typeface="Arial Unicode MS"/>
-              </a:rPr>
-              <a:t>重做在线策略开发</a:t>
-            </a:r>
-          </a:p>
-        </p:txBody>
-      </p:sp>
-      <p:sp>
-        <p:nvSpPr>
-          <p:cNvPr id="7" name="">
-            <a:extLst xmlns:a="http://schemas.openxmlformats.org/drawingml/2006/main">
-              <a:ext uri="{FF2B5EF4-FFF2-40B4-BE49-F238E27FC236}">
-                <a16:creationId xmlns:a16="http://schemas.microsoft.com/office/drawing/2014/main" id="{F9AAB801-3801-4E2F-AE79-F1F758E6A325}"/>
-              </a:ext>
-            </a:extLst>
-          </p:cNvPr>
-          <p:cNvSpPr>
-            <a:spLocks xmlns:a="http://schemas.openxmlformats.org/drawingml/2006/main" noGrp="1"/>
-          </p:cNvSpPr>
-          <p:nvPr/>
-        </p:nvSpPr>
-        <p:spPr>
-          <a:xfrm xmlns:a="http://schemas.openxmlformats.org/drawingml/2006/main">
-            <a:off x="4743450" y="1543050"/>
-            <a:ext cx="6762750" cy="457200"/>
-          </a:xfrm>
-          <a:prstGeom xmlns:a="http://schemas.openxmlformats.org/drawingml/2006/main" prst="rect">
-            <a:avLst/>
-          </a:prstGeom>
-          <a:noFill xmlns:a="http://schemas.openxmlformats.org/drawingml/2006/main"/>
-          <a:ln xmlns:a="http://schemas.openxmlformats.org/drawingml/2006/main" w="0">
-            <a:noFill/>
-            <a:prstDash val="solid"/>
-          </a:ln>
-        </p:spPr>
-        <p:txBody>
-          <a:bodyPr xmlns:a="http://schemas.openxmlformats.org/drawingml/2006/main" wrap="square" lIns="0" tIns="0" rIns="0" bIns="0" anchor="ctr">
-            <a:normAutofit fontScale="100000"/>
-          </a:bodyPr>
-          <a:lstStyle xmlns:a="http://schemas.openxmlformats.org/drawingml/2006/main"/>
-          <a:p xmlns:a="http://schemas.openxmlformats.org/drawingml/2006/main">
-            <a:pPr algn="l">
-              <a:lnSpc>
-                <a:spcPct val="106000"/>
-              </a:lnSpc>
-              <a:buNone/>
-              <a:defRPr sz="1350" b="0">
-                <a:solidFill>
-                  <a:srgbClr val="687681"/>
-                </a:solidFill>
-                <a:latin typeface="Arial Unicode MS"/>
-                <a:ea typeface="Arial Unicode MS"/>
-                <a:cs typeface="Arial Unicode MS"/>
-              </a:defRPr>
-            </a:pPr>
-            <a:r>
-              <a:rPr sz="1350" b="0">
-                <a:solidFill>
-                  <a:srgbClr val="687681"/>
-                </a:solidFill>
-                <a:latin typeface="Arial Unicode MS"/>
-                <a:ea typeface="Arial Unicode MS"/>
-                <a:cs typeface="Arial Unicode MS"/>
-              </a:rPr>
-              <a:t>当前 6 / 6 选择 GP rank 1；先在开发路线证明 override 有效。</a:t>
-            </a:r>
-          </a:p>
-        </p:txBody>
-      </p:sp>
-      <p:sp>
-        <p:nvSpPr>
-          <p:cNvPr id="8" name="">
-            <a:extLst xmlns:a="http://schemas.openxmlformats.org/drawingml/2006/main">
-              <a:ext uri="{FF2B5EF4-FFF2-40B4-BE49-F238E27FC236}">
-                <a16:creationId xmlns:a16="http://schemas.microsoft.com/office/drawing/2014/main" id="{8E505906-98D1-4B85-BCFA-0F82B224FEA0}"/>
-              </a:ext>
-            </a:extLst>
-          </p:cNvPr>
-          <p:cNvSpPr>
-            <a:spLocks xmlns:a="http://schemas.openxmlformats.org/drawingml/2006/main" noGrp="1"/>
-          </p:cNvSpPr>
-          <p:nvPr/>
-        </p:nvSpPr>
-        <p:spPr>
-          <a:xfrm xmlns:a="http://schemas.openxmlformats.org/drawingml/2006/main">
-            <a:off x="1371600" y="2114550"/>
-            <a:ext cx="10172700" cy="9525"/>
-          </a:xfrm>
-          <a:prstGeom xmlns:a="http://schemas.openxmlformats.org/drawingml/2006/main" prst="rect">
-            <a:avLst/>
-          </a:prstGeom>
-          <a:solidFill xmlns:a="http://schemas.openxmlformats.org/drawingml/2006/main">
-            <a:srgbClr val="C9D0D6"/>
-          </a:solidFill>
-          <a:ln xmlns:a="http://schemas.openxmlformats.org/drawingml/2006/main" w="0">
-            <a:noFill/>
-            <a:prstDash val="solid"/>
-          </a:ln>
-        </p:spPr>
-      </p:sp>
-      <p:sp>
-        <p:nvSpPr>
-          <p:cNvPr id="9" name="">
-            <a:extLst xmlns:a="http://schemas.openxmlformats.org/drawingml/2006/main">
-              <a:ext uri="{FF2B5EF4-FFF2-40B4-BE49-F238E27FC236}">
-                <a16:creationId xmlns:a16="http://schemas.microsoft.com/office/drawing/2014/main" id="{CEE8B28E-72F0-4690-AFB0-49ED13510F0A}"/>
-              </a:ext>
-            </a:extLst>
-          </p:cNvPr>
-          <p:cNvSpPr>
-            <a:spLocks xmlns:a="http://schemas.openxmlformats.org/drawingml/2006/main" noGrp="1"/>
-          </p:cNvSpPr>
-          <p:nvPr/>
-        </p:nvSpPr>
-        <p:spPr>
-          <a:xfrm xmlns:a="http://schemas.openxmlformats.org/drawingml/2006/main">
-            <a:off x="647700" y="2419350"/>
-            <a:ext cx="533400" cy="266700"/>
-          </a:xfrm>
-          <a:prstGeom xmlns:a="http://schemas.openxmlformats.org/drawingml/2006/main" prst="rect">
-            <a:avLst/>
-          </a:prstGeom>
-          <a:noFill xmlns:a="http://schemas.openxmlformats.org/drawingml/2006/main"/>
-          <a:ln xmlns:a="http://schemas.openxmlformats.org/drawingml/2006/main" w="0">
-            <a:noFill/>
-            <a:prstDash val="solid"/>
-          </a:ln>
-        </p:spPr>
-        <p:txBody>
-          <a:bodyPr xmlns:a="http://schemas.openxmlformats.org/drawingml/2006/main" wrap="square" lIns="0" tIns="0" rIns="0" bIns="0" anchor="t">
-            <a:normAutofit fontScale="100000"/>
-          </a:bodyPr>
-          <a:lstStyle xmlns:a="http://schemas.openxmlformats.org/drawingml/2006/main"/>
-          <a:p xmlns:a="http://schemas.openxmlformats.org/drawingml/2006/main">
-            <a:pPr algn="l">
-              <a:lnSpc>
-                <a:spcPct val="106000"/>
-              </a:lnSpc>
-              <a:buNone/>
-              <a:defRPr sz="1350" b="1">
-                <a:solidFill>
-                  <a:srgbClr val="C94D4D"/>
-                </a:solidFill>
-                <a:latin typeface="Arial Unicode MS"/>
-                <a:ea typeface="Arial Unicode MS"/>
-                <a:cs typeface="Arial Unicode MS"/>
-              </a:defRPr>
-            </a:pPr>
-            <a:r>
-              <a:rPr sz="1350" b="1">
-                <a:solidFill>
-                  <a:srgbClr val="C94D4D"/>
-                </a:solidFill>
-                <a:latin typeface="Arial Unicode MS"/>
-                <a:ea typeface="Arial Unicode MS"/>
-                <a:cs typeface="Arial Unicode MS"/>
-              </a:rPr>
-              <a:t>P0</a:t>
-            </a:r>
-          </a:p>
-        </p:txBody>
-      </p:sp>
-      <p:sp>
-        <p:nvSpPr>
-          <p:cNvPr id="10" name="">
-            <a:extLst xmlns:a="http://schemas.openxmlformats.org/drawingml/2006/main">
-              <a:ext uri="{FF2B5EF4-FFF2-40B4-BE49-F238E27FC236}">
-                <a16:creationId xmlns:a16="http://schemas.microsoft.com/office/drawing/2014/main" id="{02A1CE00-BFA8-46C9-8F32-DCA9E4239E76}"/>
-              </a:ext>
-            </a:extLst>
-          </p:cNvPr>
-          <p:cNvSpPr>
-            <a:spLocks xmlns:a="http://schemas.openxmlformats.org/drawingml/2006/main" noGrp="1"/>
-          </p:cNvSpPr>
-          <p:nvPr/>
-        </p:nvSpPr>
-        <p:spPr>
-          <a:xfrm xmlns:a="http://schemas.openxmlformats.org/drawingml/2006/main">
-            <a:off x="1371600" y="2400300"/>
-            <a:ext cx="3238500" cy="323850"/>
-          </a:xfrm>
-          <a:prstGeom xmlns:a="http://schemas.openxmlformats.org/drawingml/2006/main" prst="rect">
-            <a:avLst/>
-          </a:prstGeom>
-          <a:noFill xmlns:a="http://schemas.openxmlformats.org/drawingml/2006/main"/>
-          <a:ln xmlns:a="http://schemas.openxmlformats.org/drawingml/2006/main" w="0">
-            <a:noFill/>
-            <a:prstDash val="solid"/>
-          </a:ln>
-        </p:spPr>
-        <p:txBody>
-          <a:bodyPr xmlns:a="http://schemas.openxmlformats.org/drawingml/2006/main" wrap="square" lIns="0" tIns="0" rIns="0" bIns="0" anchor="t">
-            <a:normAutofit fontScale="100000"/>
-          </a:bodyPr>
-          <a:lstStyle xmlns:a="http://schemas.openxmlformats.org/drawingml/2006/main"/>
-          <a:p xmlns:a="http://schemas.openxmlformats.org/drawingml/2006/main">
-            <a:pPr algn="l">
-              <a:lnSpc>
-                <a:spcPct val="106000"/>
-              </a:lnSpc>
-              <a:buNone/>
-              <a:defRPr sz="1725" b="1">
-                <a:solidFill>
-                  <a:srgbClr val="17232E"/>
-                </a:solidFill>
-                <a:latin typeface="Arial Unicode MS"/>
-                <a:ea typeface="Arial Unicode MS"/>
-                <a:cs typeface="Arial Unicode MS"/>
-              </a:defRPr>
-            </a:pPr>
-            <a:r>
-              <a:rPr sz="1725" b="1">
-                <a:solidFill>
-                  <a:srgbClr val="17232E"/>
-                </a:solidFill>
-                <a:latin typeface="Arial Unicode MS"/>
-                <a:ea typeface="Arial Unicode MS"/>
-                <a:cs typeface="Arial Unicode MS"/>
-              </a:rPr>
-              <a:t>冻结 semantic skill</a:t>
-            </a:r>
-          </a:p>
-        </p:txBody>
-      </p:sp>
-      <p:sp>
-        <p:nvSpPr>
-          <p:cNvPr id="11" name="">
-            <a:extLst xmlns:a="http://schemas.openxmlformats.org/drawingml/2006/main">
-              <a:ext uri="{FF2B5EF4-FFF2-40B4-BE49-F238E27FC236}">
-                <a16:creationId xmlns:a16="http://schemas.microsoft.com/office/drawing/2014/main" id="{72CBB517-456F-4165-946E-A92E5395A813}"/>
-              </a:ext>
-            </a:extLst>
-          </p:cNvPr>
-          <p:cNvSpPr>
-            <a:spLocks xmlns:a="http://schemas.openxmlformats.org/drawingml/2006/main" noGrp="1"/>
-          </p:cNvSpPr>
-          <p:nvPr/>
-        </p:nvSpPr>
-        <p:spPr>
-          <a:xfrm xmlns:a="http://schemas.openxmlformats.org/drawingml/2006/main">
-            <a:off x="4743450" y="2400300"/>
-            <a:ext cx="6762750" cy="457200"/>
-          </a:xfrm>
-          <a:prstGeom xmlns:a="http://schemas.openxmlformats.org/drawingml/2006/main" prst="rect">
-            <a:avLst/>
-          </a:prstGeom>
-          <a:noFill xmlns:a="http://schemas.openxmlformats.org/drawingml/2006/main"/>
-          <a:ln xmlns:a="http://schemas.openxmlformats.org/drawingml/2006/main" w="0">
-            <a:noFill/>
-            <a:prstDash val="solid"/>
-          </a:ln>
-        </p:spPr>
-        <p:txBody>
-          <a:bodyPr xmlns:a="http://schemas.openxmlformats.org/drawingml/2006/main" wrap="square" lIns="0" tIns="0" rIns="0" bIns="0" anchor="ctr">
-            <a:normAutofit fontScale="100000"/>
-          </a:bodyPr>
-          <a:lstStyle xmlns:a="http://schemas.openxmlformats.org/drawingml/2006/main"/>
-          <a:p xmlns:a="http://schemas.openxmlformats.org/drawingml/2006/main">
-            <a:pPr algn="l">
-              <a:lnSpc>
-                <a:spcPct val="106000"/>
-              </a:lnSpc>
-              <a:buNone/>
-              <a:defRPr sz="1350" b="0">
-                <a:solidFill>
-                  <a:srgbClr val="687681"/>
-                </a:solidFill>
-                <a:latin typeface="Arial Unicode MS"/>
-                <a:ea typeface="Arial Unicode MS"/>
-                <a:cs typeface="Arial Unicode MS"/>
-              </a:defRPr>
-            </a:pPr>
-            <a:r>
-              <a:rPr sz="1350" b="0">
-                <a:solidFill>
-                  <a:srgbClr val="687681"/>
-                </a:solidFill>
-                <a:latin typeface="Arial Unicode MS"/>
-                <a:ea typeface="Arial Unicode MS"/>
-                <a:cs typeface="Arial Unicode MS"/>
-              </a:rPr>
-              <a:t>新任务上锁定 skill、compiler、split 与 baseline 后再看结果。</a:t>
-            </a:r>
-          </a:p>
-        </p:txBody>
-      </p:sp>
-      <p:sp>
-        <p:nvSpPr>
-          <p:cNvPr id="12" name="">
-            <a:extLst xmlns:a="http://schemas.openxmlformats.org/drawingml/2006/main">
-              <a:ext uri="{FF2B5EF4-FFF2-40B4-BE49-F238E27FC236}">
-                <a16:creationId xmlns:a16="http://schemas.microsoft.com/office/drawing/2014/main" id="{ADB76C62-0456-403B-92BC-5458F97BAC5B}"/>
-              </a:ext>
-            </a:extLst>
-          </p:cNvPr>
-          <p:cNvSpPr>
-            <a:spLocks xmlns:a="http://schemas.openxmlformats.org/drawingml/2006/main" noGrp="1"/>
-          </p:cNvSpPr>
-          <p:nvPr/>
-        </p:nvSpPr>
-        <p:spPr>
-          <a:xfrm xmlns:a="http://schemas.openxmlformats.org/drawingml/2006/main">
-            <a:off x="1371600" y="2971800"/>
-            <a:ext cx="10172700" cy="9525"/>
-          </a:xfrm>
-          <a:prstGeom xmlns:a="http://schemas.openxmlformats.org/drawingml/2006/main" prst="rect">
-            <a:avLst/>
-          </a:prstGeom>
-          <a:solidFill xmlns:a="http://schemas.openxmlformats.org/drawingml/2006/main">
-            <a:srgbClr val="C9D0D6"/>
-          </a:solidFill>
-          <a:ln xmlns:a="http://schemas.openxmlformats.org/drawingml/2006/main" w="0">
-            <a:noFill/>
-            <a:prstDash val="solid"/>
-          </a:ln>
-        </p:spPr>
-      </p:sp>
-      <p:sp>
-        <p:nvSpPr>
-          <p:cNvPr id="13" name="">
-            <a:extLst xmlns:a="http://schemas.openxmlformats.org/drawingml/2006/main">
-              <a:ext uri="{FF2B5EF4-FFF2-40B4-BE49-F238E27FC236}">
-                <a16:creationId xmlns:a16="http://schemas.microsoft.com/office/drawing/2014/main" id="{7D166283-39F4-451C-ADD9-AF6C52682CC8}"/>
-              </a:ext>
-            </a:extLst>
-          </p:cNvPr>
-          <p:cNvSpPr>
-            <a:spLocks xmlns:a="http://schemas.openxmlformats.org/drawingml/2006/main" noGrp="1"/>
-          </p:cNvSpPr>
-          <p:nvPr/>
-        </p:nvSpPr>
-        <p:spPr>
-          <a:xfrm xmlns:a="http://schemas.openxmlformats.org/drawingml/2006/main">
-            <a:off x="647700" y="3276600"/>
-            <a:ext cx="533400" cy="266700"/>
-          </a:xfrm>
-          <a:prstGeom xmlns:a="http://schemas.openxmlformats.org/drawingml/2006/main" prst="rect">
-            <a:avLst/>
-          </a:prstGeom>
-          <a:noFill xmlns:a="http://schemas.openxmlformats.org/drawingml/2006/main"/>
-          <a:ln xmlns:a="http://schemas.openxmlformats.org/drawingml/2006/main" w="0">
-            <a:noFill/>
-            <a:prstDash val="solid"/>
-          </a:ln>
-        </p:spPr>
-        <p:txBody>
-          <a:bodyPr xmlns:a="http://schemas.openxmlformats.org/drawingml/2006/main" wrap="square" lIns="0" tIns="0" rIns="0" bIns="0" anchor="t">
-            <a:normAutofit fontScale="100000"/>
-          </a:bodyPr>
-          <a:lstStyle xmlns:a="http://schemas.openxmlformats.org/drawingml/2006/main"/>
-          <a:p xmlns:a="http://schemas.openxmlformats.org/drawingml/2006/main">
-            <a:pPr algn="l">
-              <a:lnSpc>
-                <a:spcPct val="106000"/>
-              </a:lnSpc>
-              <a:buNone/>
-              <a:defRPr sz="1350" b="1">
-                <a:solidFill>
-                  <a:srgbClr val="D99A33"/>
-                </a:solidFill>
-                <a:latin typeface="Arial Unicode MS"/>
-                <a:ea typeface="Arial Unicode MS"/>
-                <a:cs typeface="Arial Unicode MS"/>
-              </a:defRPr>
-            </a:pPr>
-            <a:r>
-              <a:rPr sz="1350" b="1">
-                <a:solidFill>
-                  <a:srgbClr val="D99A33"/>
-                </a:solidFill>
-                <a:latin typeface="Arial Unicode MS"/>
-                <a:ea typeface="Arial Unicode MS"/>
-                <a:cs typeface="Arial Unicode MS"/>
-              </a:rPr>
-              <a:t>P0</a:t>
-            </a:r>
-          </a:p>
-        </p:txBody>
-      </p:sp>
-      <p:sp>
-        <p:nvSpPr>
-          <p:cNvPr id="14" name="">
-            <a:extLst xmlns:a="http://schemas.openxmlformats.org/drawingml/2006/main">
-              <a:ext uri="{FF2B5EF4-FFF2-40B4-BE49-F238E27FC236}">
-                <a16:creationId xmlns:a16="http://schemas.microsoft.com/office/drawing/2014/main" id="{7FFDF158-CAA5-4D3F-8CC4-6B6B8C524796}"/>
-              </a:ext>
-            </a:extLst>
-          </p:cNvPr>
-          <p:cNvSpPr>
-            <a:spLocks xmlns:a="http://schemas.openxmlformats.org/drawingml/2006/main" noGrp="1"/>
-          </p:cNvSpPr>
-          <p:nvPr/>
-        </p:nvSpPr>
-        <p:spPr>
-          <a:xfrm xmlns:a="http://schemas.openxmlformats.org/drawingml/2006/main">
-            <a:off x="1371600" y="3257550"/>
-            <a:ext cx="3238500" cy="323850"/>
-          </a:xfrm>
-          <a:prstGeom xmlns:a="http://schemas.openxmlformats.org/drawingml/2006/main" prst="rect">
-            <a:avLst/>
-          </a:prstGeom>
-          <a:noFill xmlns:a="http://schemas.openxmlformats.org/drawingml/2006/main"/>
-          <a:ln xmlns:a="http://schemas.openxmlformats.org/drawingml/2006/main" w="0">
-            <a:noFill/>
-            <a:prstDash val="solid"/>
-          </a:ln>
-        </p:spPr>
-        <p:txBody>
-          <a:bodyPr xmlns:a="http://schemas.openxmlformats.org/drawingml/2006/main" wrap="square" lIns="0" tIns="0" rIns="0" bIns="0" anchor="t">
-            <a:normAutofit fontScale="100000"/>
-          </a:bodyPr>
-          <a:lstStyle xmlns:a="http://schemas.openxmlformats.org/drawingml/2006/main"/>
-          <a:p xmlns:a="http://schemas.openxmlformats.org/drawingml/2006/main">
-            <a:pPr algn="l">
-              <a:lnSpc>
-                <a:spcPct val="106000"/>
-              </a:lnSpc>
-              <a:buNone/>
-              <a:defRPr sz="1725" b="1">
-                <a:solidFill>
-                  <a:srgbClr val="17232E"/>
-                </a:solidFill>
-                <a:latin typeface="Arial Unicode MS"/>
-                <a:ea typeface="Arial Unicode MS"/>
-                <a:cs typeface="Arial Unicode MS"/>
-              </a:defRPr>
-            </a:pPr>
-            <a:r>
-              <a:rPr sz="1725" b="1">
-                <a:solidFill>
-                  <a:srgbClr val="17232E"/>
-                </a:solidFill>
-                <a:latin typeface="Arial Unicode MS"/>
-                <a:ea typeface="Arial Unicode MS"/>
-                <a:cs typeface="Arial Unicode MS"/>
-              </a:rPr>
-              <a:t>前瞻实验</a:t>
-            </a:r>
-          </a:p>
-        </p:txBody>
-      </p:sp>
-      <p:sp>
-        <p:nvSpPr>
-          <p:cNvPr id="15" name="">
-            <a:extLst xmlns:a="http://schemas.openxmlformats.org/drawingml/2006/main">
-              <a:ext uri="{FF2B5EF4-FFF2-40B4-BE49-F238E27FC236}">
-                <a16:creationId xmlns:a16="http://schemas.microsoft.com/office/drawing/2014/main" id="{C3D931FF-9BA2-45C1-9F7B-E8B41903B234}"/>
-              </a:ext>
-            </a:extLst>
-          </p:cNvPr>
-          <p:cNvSpPr>
-            <a:spLocks xmlns:a="http://schemas.openxmlformats.org/drawingml/2006/main" noGrp="1"/>
-          </p:cNvSpPr>
-          <p:nvPr/>
-        </p:nvSpPr>
-        <p:spPr>
-          <a:xfrm xmlns:a="http://schemas.openxmlformats.org/drawingml/2006/main">
-            <a:off x="4743450" y="3257550"/>
-            <a:ext cx="6762750" cy="457200"/>
-          </a:xfrm>
-          <a:prstGeom xmlns:a="http://schemas.openxmlformats.org/drawingml/2006/main" prst="rect">
-            <a:avLst/>
-          </a:prstGeom>
-          <a:noFill xmlns:a="http://schemas.openxmlformats.org/drawingml/2006/main"/>
-          <a:ln xmlns:a="http://schemas.openxmlformats.org/drawingml/2006/main" w="0">
-            <a:noFill/>
-            <a:prstDash val="solid"/>
-          </a:ln>
-        </p:spPr>
-        <p:txBody>
-          <a:bodyPr xmlns:a="http://schemas.openxmlformats.org/drawingml/2006/main" wrap="square" lIns="0" tIns="0" rIns="0" bIns="0" anchor="ctr">
-            <a:normAutofit fontScale="100000"/>
-          </a:bodyPr>
-          <a:lstStyle xmlns:a="http://schemas.openxmlformats.org/drawingml/2006/main"/>
-          <a:p xmlns:a="http://schemas.openxmlformats.org/drawingml/2006/main">
-            <a:pPr algn="l">
-              <a:lnSpc>
-                <a:spcPct val="106000"/>
-              </a:lnSpc>
-              <a:buNone/>
-              <a:defRPr sz="1350" b="0">
-                <a:solidFill>
-                  <a:srgbClr val="687681"/>
-                </a:solidFill>
-                <a:latin typeface="Arial Unicode MS"/>
-                <a:ea typeface="Arial Unicode MS"/>
-                <a:cs typeface="Arial Unicode MS"/>
-              </a:defRPr>
-            </a:pPr>
-            <a:r>
-              <a:rPr sz="1350" b="0">
-                <a:solidFill>
-                  <a:srgbClr val="687681"/>
-                </a:solidFill>
-                <a:latin typeface="Arial Unicode MS"/>
-                <a:ea typeface="Arial Unicode MS"/>
-                <a:cs typeface="Arial Unicode MS"/>
-              </a:rPr>
-              <a:t>完成至少一条真实 wet-lab / prospective campaign，直接比较样本效率。</a:t>
-            </a:r>
-          </a:p>
-        </p:txBody>
-      </p:sp>
-      <p:sp>
-        <p:nvSpPr>
-          <p:cNvPr id="16" name="">
-            <a:extLst xmlns:a="http://schemas.openxmlformats.org/drawingml/2006/main">
-              <a:ext uri="{FF2B5EF4-FFF2-40B4-BE49-F238E27FC236}">
-                <a16:creationId xmlns:a16="http://schemas.microsoft.com/office/drawing/2014/main" id="{707788CB-DFEF-4297-A231-3BE4E36F0580}"/>
-              </a:ext>
-            </a:extLst>
-          </p:cNvPr>
-          <p:cNvSpPr>
-            <a:spLocks xmlns:a="http://schemas.openxmlformats.org/drawingml/2006/main" noGrp="1"/>
-          </p:cNvSpPr>
-          <p:nvPr/>
-        </p:nvSpPr>
-        <p:spPr>
-          <a:xfrm xmlns:a="http://schemas.openxmlformats.org/drawingml/2006/main">
-            <a:off x="1371600" y="3829050"/>
-            <a:ext cx="10172700" cy="9525"/>
-          </a:xfrm>
-          <a:prstGeom xmlns:a="http://schemas.openxmlformats.org/drawingml/2006/main" prst="rect">
-            <a:avLst/>
-          </a:prstGeom>
-          <a:solidFill xmlns:a="http://schemas.openxmlformats.org/drawingml/2006/main">
-            <a:srgbClr val="C9D0D6"/>
-          </a:solidFill>
-          <a:ln xmlns:a="http://schemas.openxmlformats.org/drawingml/2006/main" w="0">
-            <a:noFill/>
-            <a:prstDash val="solid"/>
-          </a:ln>
-        </p:spPr>
-      </p:sp>
-      <p:sp>
-        <p:nvSpPr>
-          <p:cNvPr id="17" name="">
-            <a:extLst xmlns:a="http://schemas.openxmlformats.org/drawingml/2006/main">
-              <a:ext uri="{FF2B5EF4-FFF2-40B4-BE49-F238E27FC236}">
-                <a16:creationId xmlns:a16="http://schemas.microsoft.com/office/drawing/2014/main" id="{9DC6F96D-97D8-44DB-9E90-E4814818FA91}"/>
-              </a:ext>
-            </a:extLst>
-          </p:cNvPr>
-          <p:cNvSpPr>
-            <a:spLocks xmlns:a="http://schemas.openxmlformats.org/drawingml/2006/main" noGrp="1"/>
-          </p:cNvSpPr>
-          <p:nvPr/>
-        </p:nvSpPr>
-        <p:spPr>
-          <a:xfrm xmlns:a="http://schemas.openxmlformats.org/drawingml/2006/main">
-            <a:off x="647700" y="4133850"/>
-            <a:ext cx="533400" cy="266700"/>
-          </a:xfrm>
-          <a:prstGeom xmlns:a="http://schemas.openxmlformats.org/drawingml/2006/main" prst="rect">
-            <a:avLst/>
-          </a:prstGeom>
-          <a:noFill xmlns:a="http://schemas.openxmlformats.org/drawingml/2006/main"/>
-          <a:ln xmlns:a="http://schemas.openxmlformats.org/drawingml/2006/main" w="0">
-            <a:noFill/>
-            <a:prstDash val="solid"/>
-          </a:ln>
-        </p:spPr>
-        <p:txBody>
-          <a:bodyPr xmlns:a="http://schemas.openxmlformats.org/drawingml/2006/main" wrap="square" lIns="0" tIns="0" rIns="0" bIns="0" anchor="t">
-            <a:normAutofit fontScale="100000"/>
-          </a:bodyPr>
-          <a:lstStyle xmlns:a="http://schemas.openxmlformats.org/drawingml/2006/main"/>
-          <a:p xmlns:a="http://schemas.openxmlformats.org/drawingml/2006/main">
-            <a:pPr algn="l">
-              <a:lnSpc>
-                <a:spcPct val="106000"/>
-              </a:lnSpc>
-              <a:buNone/>
-              <a:defRPr sz="1350" b="1">
-                <a:solidFill>
-                  <a:srgbClr val="D99A33"/>
-                </a:solidFill>
-                <a:latin typeface="Arial Unicode MS"/>
-                <a:ea typeface="Arial Unicode MS"/>
-                <a:cs typeface="Arial Unicode MS"/>
-              </a:defRPr>
-            </a:pPr>
-            <a:r>
-              <a:rPr sz="1350" b="1">
-                <a:solidFill>
-                  <a:srgbClr val="D99A33"/>
-                </a:solidFill>
-                <a:latin typeface="Arial Unicode MS"/>
-                <a:ea typeface="Arial Unicode MS"/>
-                <a:cs typeface="Arial Unicode MS"/>
-              </a:rPr>
-              <a:t>P1</a:t>
-            </a:r>
-          </a:p>
-        </p:txBody>
-      </p:sp>
-      <p:sp>
-        <p:nvSpPr>
-          <p:cNvPr id="18" name="">
-            <a:extLst xmlns:a="http://schemas.openxmlformats.org/drawingml/2006/main">
-              <a:ext uri="{FF2B5EF4-FFF2-40B4-BE49-F238E27FC236}">
-                <a16:creationId xmlns:a16="http://schemas.microsoft.com/office/drawing/2014/main" id="{A17C505A-A3F2-429F-BC0A-B56CE684D1D0}"/>
-              </a:ext>
-            </a:extLst>
-          </p:cNvPr>
-          <p:cNvSpPr>
-            <a:spLocks xmlns:a="http://schemas.openxmlformats.org/drawingml/2006/main" noGrp="1"/>
-          </p:cNvSpPr>
-          <p:nvPr/>
-        </p:nvSpPr>
-        <p:spPr>
-          <a:xfrm xmlns:a="http://schemas.openxmlformats.org/drawingml/2006/main">
-            <a:off x="1371600" y="4114800"/>
-            <a:ext cx="3238500" cy="323850"/>
-          </a:xfrm>
-          <a:prstGeom xmlns:a="http://schemas.openxmlformats.org/drawingml/2006/main" prst="rect">
-            <a:avLst/>
-          </a:prstGeom>
-          <a:noFill xmlns:a="http://schemas.openxmlformats.org/drawingml/2006/main"/>
-          <a:ln xmlns:a="http://schemas.openxmlformats.org/drawingml/2006/main" w="0">
-            <a:noFill/>
-            <a:prstDash val="solid"/>
-          </a:ln>
-        </p:spPr>
-        <p:txBody>
-          <a:bodyPr xmlns:a="http://schemas.openxmlformats.org/drawingml/2006/main" wrap="square" lIns="0" tIns="0" rIns="0" bIns="0" anchor="t">
-            <a:normAutofit fontScale="100000"/>
-          </a:bodyPr>
-          <a:lstStyle xmlns:a="http://schemas.openxmlformats.org/drawingml/2006/main"/>
-          <a:p xmlns:a="http://schemas.openxmlformats.org/drawingml/2006/main">
-            <a:pPr algn="l">
-              <a:lnSpc>
-                <a:spcPct val="106000"/>
-              </a:lnSpc>
-              <a:buNone/>
-              <a:defRPr sz="1725" b="1">
-                <a:solidFill>
-                  <a:srgbClr val="17232E"/>
-                </a:solidFill>
-                <a:latin typeface="Arial Unicode MS"/>
-                <a:ea typeface="Arial Unicode MS"/>
-                <a:cs typeface="Arial Unicode MS"/>
-              </a:defRPr>
-            </a:pPr>
-            <a:r>
-              <a:rPr sz="1725" b="1">
-                <a:solidFill>
-                  <a:srgbClr val="17232E"/>
-                </a:solidFill>
-                <a:latin typeface="Arial Unicode MS"/>
-                <a:ea typeface="Arial Unicode MS"/>
-                <a:cs typeface="Arial Unicode MS"/>
-              </a:rPr>
-              <a:t>贡献归因</a:t>
-            </a:r>
-          </a:p>
-        </p:txBody>
-      </p:sp>
-      <p:sp>
-        <p:nvSpPr>
-          <p:cNvPr id="19" name="">
-            <a:extLst xmlns:a="http://schemas.openxmlformats.org/drawingml/2006/main">
-              <a:ext uri="{FF2B5EF4-FFF2-40B4-BE49-F238E27FC236}">
-                <a16:creationId xmlns:a16="http://schemas.microsoft.com/office/drawing/2014/main" id="{E7863410-6840-4F49-83CD-46D28A3E066A}"/>
-              </a:ext>
-            </a:extLst>
-          </p:cNvPr>
-          <p:cNvSpPr>
-            <a:spLocks xmlns:a="http://schemas.openxmlformats.org/drawingml/2006/main" noGrp="1"/>
-          </p:cNvSpPr>
-          <p:nvPr/>
-        </p:nvSpPr>
-        <p:spPr>
-          <a:xfrm xmlns:a="http://schemas.openxmlformats.org/drawingml/2006/main">
-            <a:off x="4743450" y="4114800"/>
-            <a:ext cx="6762750" cy="457200"/>
-          </a:xfrm>
-          <a:prstGeom xmlns:a="http://schemas.openxmlformats.org/drawingml/2006/main" prst="rect">
-            <a:avLst/>
-          </a:prstGeom>
-          <a:noFill xmlns:a="http://schemas.openxmlformats.org/drawingml/2006/main"/>
-          <a:ln xmlns:a="http://schemas.openxmlformats.org/drawingml/2006/main" w="0">
-            <a:noFill/>
-            <a:prstDash val="solid"/>
-          </a:ln>
-        </p:spPr>
-        <p:txBody>
-          <a:bodyPr xmlns:a="http://schemas.openxmlformats.org/drawingml/2006/main" wrap="square" lIns="0" tIns="0" rIns="0" bIns="0" anchor="ctr">
-            <a:normAutofit fontScale="100000"/>
-          </a:bodyPr>
-          <a:lstStyle xmlns:a="http://schemas.openxmlformats.org/drawingml/2006/main"/>
-          <a:p xmlns:a="http://schemas.openxmlformats.org/drawingml/2006/main">
-            <a:pPr algn="l">
-              <a:lnSpc>
-                <a:spcPct val="106000"/>
-              </a:lnSpc>
-              <a:buNone/>
-              <a:defRPr sz="1350" b="0">
-                <a:solidFill>
-                  <a:srgbClr val="687681"/>
-                </a:solidFill>
-                <a:latin typeface="Arial Unicode MS"/>
-                <a:ea typeface="Arial Unicode MS"/>
-                <a:cs typeface="Arial Unicode MS"/>
-              </a:defRPr>
-            </a:pPr>
-            <a:r>
-              <a:rPr sz="1350" b="0">
-                <a:solidFill>
-                  <a:srgbClr val="687681"/>
-                </a:solidFill>
-                <a:latin typeface="Arial Unicode MS"/>
-                <a:ea typeface="Arial Unicode MS"/>
-                <a:cs typeface="Arial Unicode MS"/>
-              </a:rPr>
-              <a:t>移除 source evidence、semantic rule、prior 与 critic，做同 seed 消融。</a:t>
-            </a:r>
-          </a:p>
-        </p:txBody>
-      </p:sp>
-      <p:sp>
-        <p:nvSpPr>
-          <p:cNvPr id="20" name="">
-            <a:extLst xmlns:a="http://schemas.openxmlformats.org/drawingml/2006/main">
-              <a:ext uri="{FF2B5EF4-FFF2-40B4-BE49-F238E27FC236}">
-                <a16:creationId xmlns:a16="http://schemas.microsoft.com/office/drawing/2014/main" id="{15901B31-7FA9-4847-B366-CCF2995B1B1D}"/>
-              </a:ext>
-            </a:extLst>
-          </p:cNvPr>
-          <p:cNvSpPr>
-            <a:spLocks xmlns:a="http://schemas.openxmlformats.org/drawingml/2006/main" noGrp="1"/>
-          </p:cNvSpPr>
-          <p:nvPr/>
-        </p:nvSpPr>
-        <p:spPr>
-          <a:xfrm xmlns:a="http://schemas.openxmlformats.org/drawingml/2006/main">
-            <a:off x="1371600" y="4686300"/>
-            <a:ext cx="10172700" cy="9525"/>
-          </a:xfrm>
-          <a:prstGeom xmlns:a="http://schemas.openxmlformats.org/drawingml/2006/main" prst="rect">
-            <a:avLst/>
-          </a:prstGeom>
-          <a:solidFill xmlns:a="http://schemas.openxmlformats.org/drawingml/2006/main">
-            <a:srgbClr val="C9D0D6"/>
-          </a:solidFill>
-          <a:ln xmlns:a="http://schemas.openxmlformats.org/drawingml/2006/main" w="0">
-            <a:noFill/>
-            <a:prstDash val="solid"/>
-          </a:ln>
-        </p:spPr>
-      </p:sp>
-      <p:sp>
-        <p:nvSpPr>
-          <p:cNvPr id="21" name="">
-            <a:extLst xmlns:a="http://schemas.openxmlformats.org/drawingml/2006/main">
-              <a:ext uri="{FF2B5EF4-FFF2-40B4-BE49-F238E27FC236}">
-                <a16:creationId xmlns:a16="http://schemas.microsoft.com/office/drawing/2014/main" id="{8A2C0634-FE0A-4D42-8FDA-CDF1A31B804E}"/>
-              </a:ext>
-            </a:extLst>
-          </p:cNvPr>
-          <p:cNvSpPr>
-            <a:spLocks xmlns:a="http://schemas.openxmlformats.org/drawingml/2006/main" noGrp="1"/>
-          </p:cNvSpPr>
-          <p:nvPr/>
-        </p:nvSpPr>
-        <p:spPr>
-          <a:xfrm xmlns:a="http://schemas.openxmlformats.org/drawingml/2006/main">
-            <a:off x="647700" y="4991100"/>
-            <a:ext cx="533400" cy="266700"/>
-          </a:xfrm>
-          <a:prstGeom xmlns:a="http://schemas.openxmlformats.org/drawingml/2006/main" prst="rect">
-            <a:avLst/>
-          </a:prstGeom>
-          <a:noFill xmlns:a="http://schemas.openxmlformats.org/drawingml/2006/main"/>
-          <a:ln xmlns:a="http://schemas.openxmlformats.org/drawingml/2006/main" w="0">
-            <a:noFill/>
-            <a:prstDash val="solid"/>
-          </a:ln>
-        </p:spPr>
-        <p:txBody>
-          <a:bodyPr xmlns:a="http://schemas.openxmlformats.org/drawingml/2006/main" wrap="square" lIns="0" tIns="0" rIns="0" bIns="0" anchor="t">
-            <a:normAutofit fontScale="100000"/>
-          </a:bodyPr>
-          <a:lstStyle xmlns:a="http://schemas.openxmlformats.org/drawingml/2006/main"/>
-          <a:p xmlns:a="http://schemas.openxmlformats.org/drawingml/2006/main">
-            <a:pPr algn="l">
-              <a:lnSpc>
-                <a:spcPct val="106000"/>
-              </a:lnSpc>
-              <a:buNone/>
-              <a:defRPr sz="1350" b="1">
-                <a:solidFill>
-                  <a:srgbClr val="2F6FB6"/>
-                </a:solidFill>
-                <a:latin typeface="Arial Unicode MS"/>
-                <a:ea typeface="Arial Unicode MS"/>
-                <a:cs typeface="Arial Unicode MS"/>
-              </a:defRPr>
-            </a:pPr>
-            <a:r>
-              <a:rPr sz="1350" b="1">
-                <a:solidFill>
-                  <a:srgbClr val="2F6FB6"/>
-                </a:solidFill>
-                <a:latin typeface="Arial Unicode MS"/>
-                <a:ea typeface="Arial Unicode MS"/>
-                <a:cs typeface="Arial Unicode MS"/>
-              </a:rPr>
-              <a:t>P2</a:t>
-            </a:r>
-          </a:p>
-        </p:txBody>
-      </p:sp>
-      <p:sp>
-        <p:nvSpPr>
-          <p:cNvPr id="22" name="">
-            <a:extLst xmlns:a="http://schemas.openxmlformats.org/drawingml/2006/main">
-              <a:ext uri="{FF2B5EF4-FFF2-40B4-BE49-F238E27FC236}">
-                <a16:creationId xmlns:a16="http://schemas.microsoft.com/office/drawing/2014/main" id="{53221302-B7E0-4545-B48B-D4BDC88A6B0C}"/>
-              </a:ext>
-            </a:extLst>
-          </p:cNvPr>
-          <p:cNvSpPr>
-            <a:spLocks xmlns:a="http://schemas.openxmlformats.org/drawingml/2006/main" noGrp="1"/>
-          </p:cNvSpPr>
-          <p:nvPr/>
-        </p:nvSpPr>
-        <p:spPr>
-          <a:xfrm xmlns:a="http://schemas.openxmlformats.org/drawingml/2006/main">
-            <a:off x="1371600" y="4972050"/>
-            <a:ext cx="3238500" cy="323850"/>
-          </a:xfrm>
-          <a:prstGeom xmlns:a="http://schemas.openxmlformats.org/drawingml/2006/main" prst="rect">
-            <a:avLst/>
-          </a:prstGeom>
-          <a:noFill xmlns:a="http://schemas.openxmlformats.org/drawingml/2006/main"/>
-          <a:ln xmlns:a="http://schemas.openxmlformats.org/drawingml/2006/main" w="0">
-            <a:noFill/>
-            <a:prstDash val="solid"/>
-          </a:ln>
-        </p:spPr>
-        <p:txBody>
-          <a:bodyPr xmlns:a="http://schemas.openxmlformats.org/drawingml/2006/main" wrap="square" lIns="0" tIns="0" rIns="0" bIns="0" anchor="t">
-            <a:normAutofit fontScale="100000"/>
-          </a:bodyPr>
-          <a:lstStyle xmlns:a="http://schemas.openxmlformats.org/drawingml/2006/main"/>
-          <a:p xmlns:a="http://schemas.openxmlformats.org/drawingml/2006/main">
-            <a:pPr algn="l">
-              <a:lnSpc>
-                <a:spcPct val="106000"/>
-              </a:lnSpc>
-              <a:buNone/>
-              <a:defRPr sz="1725" b="1">
-                <a:solidFill>
-                  <a:srgbClr val="17232E"/>
-                </a:solidFill>
-                <a:latin typeface="Arial Unicode MS"/>
-                <a:ea typeface="Arial Unicode MS"/>
-                <a:cs typeface="Arial Unicode MS"/>
-              </a:defRPr>
-            </a:pPr>
-            <a:r>
-              <a:rPr sz="1725" b="1">
-                <a:solidFill>
-                  <a:srgbClr val="17232E"/>
-                </a:solidFill>
-                <a:latin typeface="Arial Unicode MS"/>
-                <a:ea typeface="Arial Unicode MS"/>
-                <a:cs typeface="Arial Unicode MS"/>
-              </a:rPr>
-              <a:t>开放复现</a:t>
-            </a:r>
-          </a:p>
-        </p:txBody>
-      </p:sp>
-      <p:sp>
-        <p:nvSpPr>
-          <p:cNvPr id="23" name="">
-            <a:extLst xmlns:a="http://schemas.openxmlformats.org/drawingml/2006/main">
-              <a:ext uri="{FF2B5EF4-FFF2-40B4-BE49-F238E27FC236}">
-                <a16:creationId xmlns:a16="http://schemas.microsoft.com/office/drawing/2014/main" id="{055FA084-C0BF-4D28-B234-B18299B6C8C0}"/>
-              </a:ext>
-            </a:extLst>
-          </p:cNvPr>
-          <p:cNvSpPr>
-            <a:spLocks xmlns:a="http://schemas.openxmlformats.org/drawingml/2006/main" noGrp="1"/>
-          </p:cNvSpPr>
-          <p:nvPr/>
-        </p:nvSpPr>
-        <p:spPr>
-          <a:xfrm xmlns:a="http://schemas.openxmlformats.org/drawingml/2006/main">
-            <a:off x="4743450" y="4972050"/>
-            <a:ext cx="6762750" cy="457200"/>
-          </a:xfrm>
-          <a:prstGeom xmlns:a="http://schemas.openxmlformats.org/drawingml/2006/main" prst="rect">
-            <a:avLst/>
-          </a:prstGeom>
-          <a:noFill xmlns:a="http://schemas.openxmlformats.org/drawingml/2006/main"/>
-          <a:ln xmlns:a="http://schemas.openxmlformats.org/drawingml/2006/main" w="0">
-            <a:noFill/>
-            <a:prstDash val="solid"/>
-          </a:ln>
-        </p:spPr>
-        <p:txBody>
-          <a:bodyPr xmlns:a="http://schemas.openxmlformats.org/drawingml/2006/main" wrap="square" lIns="0" tIns="0" rIns="0" bIns="0" anchor="ctr">
-            <a:normAutofit fontScale="100000"/>
-          </a:bodyPr>
-          <a:lstStyle xmlns:a="http://schemas.openxmlformats.org/drawingml/2006/main"/>
-          <a:p xmlns:a="http://schemas.openxmlformats.org/drawingml/2006/main">
-            <a:pPr algn="l">
-              <a:lnSpc>
-                <a:spcPct val="106000"/>
-              </a:lnSpc>
-              <a:buNone/>
-              <a:defRPr sz="1350" b="0">
-                <a:solidFill>
-                  <a:srgbClr val="687681"/>
-                </a:solidFill>
-                <a:latin typeface="Arial Unicode MS"/>
-                <a:ea typeface="Arial Unicode MS"/>
-                <a:cs typeface="Arial Unicode MS"/>
-              </a:defRPr>
-            </a:pPr>
-            <a:r>
-              <a:rPr sz="1350" b="0">
-                <a:solidFill>
-                  <a:srgbClr val="687681"/>
-                </a:solidFill>
-                <a:latin typeface="Arial Unicode MS"/>
-                <a:ea typeface="Arial Unicode MS"/>
-                <a:cs typeface="Arial Unicode MS"/>
-              </a:rPr>
-              <a:t>公开代码、数据、完整 trace、模型版本、失败记录和精确统计口径。</a:t>
-            </a:r>
-          </a:p>
-        </p:txBody>
-      </p:sp>
-      <p:sp>
-        <p:nvSpPr>
-          <p:cNvPr id="24" name="">
-            <a:extLst xmlns:a="http://schemas.openxmlformats.org/drawingml/2006/main">
-              <a:ext uri="{FF2B5EF4-FFF2-40B4-BE49-F238E27FC236}">
-                <a16:creationId xmlns:a16="http://schemas.microsoft.com/office/drawing/2014/main" id="{DF50E354-0DEC-4E1D-B4DA-0E5B094C1972}"/>
-              </a:ext>
-            </a:extLst>
-          </p:cNvPr>
-          <p:cNvSpPr>
-            <a:spLocks xmlns:a="http://schemas.openxmlformats.org/drawingml/2006/main" noGrp="1"/>
-          </p:cNvSpPr>
-          <p:nvPr/>
-        </p:nvSpPr>
-        <p:spPr>
-          <a:xfrm xmlns:a="http://schemas.openxmlformats.org/drawingml/2006/main">
-            <a:off x="1371600" y="5543550"/>
-            <a:ext cx="10172700" cy="9525"/>
-          </a:xfrm>
-          <a:prstGeom xmlns:a="http://schemas.openxmlformats.org/drawingml/2006/main" prst="rect">
-            <a:avLst/>
-          </a:prstGeom>
-          <a:solidFill xmlns:a="http://schemas.openxmlformats.org/drawingml/2006/main">
-            <a:srgbClr val="C9D0D6"/>
-          </a:solidFill>
-          <a:ln xmlns:a="http://schemas.openxmlformats.org/drawingml/2006/main" w="0">
-            <a:noFill/>
-            <a:prstDash val="solid"/>
-          </a:ln>
-        </p:spPr>
-      </p:sp>
-      <p:sp>
-        <p:nvSpPr>
-          <p:cNvPr id="25" name="">
-            <a:extLst xmlns:a="http://schemas.openxmlformats.org/drawingml/2006/main">
-              <a:ext uri="{FF2B5EF4-FFF2-40B4-BE49-F238E27FC236}">
-                <a16:creationId xmlns:a16="http://schemas.microsoft.com/office/drawing/2014/main" id="{EFFB2D73-A445-4401-9B98-BF6FC9E8A674}"/>
-              </a:ext>
-            </a:extLst>
-          </p:cNvPr>
-          <p:cNvSpPr>
-            <a:spLocks xmlns:a="http://schemas.openxmlformats.org/drawingml/2006/main" noGrp="1"/>
-          </p:cNvSpPr>
-          <p:nvPr/>
-        </p:nvSpPr>
-        <p:spPr>
-          <a:xfrm xmlns:a="http://schemas.openxmlformats.org/drawingml/2006/main">
-            <a:off x="647700" y="6600825"/>
-            <a:ext cx="10896600" cy="133350"/>
-          </a:xfrm>
-          <a:prstGeom xmlns:a="http://schemas.openxmlformats.org/drawingml/2006/main" prst="rect">
-            <a:avLst/>
-          </a:prstGeom>
-          <a:noFill xmlns:a="http://schemas.openxmlformats.org/drawingml/2006/main"/>
-          <a:ln xmlns:a="http://schemas.openxmlformats.org/drawingml/2006/main" w="0">
-            <a:noFill/>
-            <a:prstDash val="solid"/>
-          </a:ln>
-        </p:spPr>
-        <p:txBody>
-          <a:bodyPr xmlns:a="http://schemas.openxmlformats.org/drawingml/2006/main" wrap="square" lIns="0" tIns="0" rIns="0" bIns="0" anchor="t">
-            <a:normAutofit fontScale="100000"/>
-          </a:bodyPr>
-          <a:lstStyle xmlns:a="http://schemas.openxmlformats.org/drawingml/2006/main"/>
-          <a:p xmlns:a="http://schemas.openxmlformats.org/drawingml/2006/main">
-            <a:pPr algn="r">
-              <a:lnSpc>
-                <a:spcPct val="106000"/>
-              </a:lnSpc>
-              <a:buNone/>
               <a:defRPr sz="750" b="0">
                 <a:solidFill>
                   <a:srgbClr val="8B959D"/>
@@ -7104,15 +6054,37 @@
                 <a:ea typeface="Arial Unicode MS"/>
                 <a:cs typeface="Arial Unicode MS"/>
               </a:rPr>
-              <a:t>CARE 2.0 · online LLM evidence update · 2026-08-24</a:t>
-            </a:r>
-          </a:p>
-        </p:txBody>
-      </p:sp>
+              <a:t>CARE 2.0 · source-outcome audit · 2026-08-24</a:t>
+            </a:r>
+          </a:p>
+        </p:txBody>
+      </p:sp>
+      <p:pic>
+        <p:nvPicPr>
+          <p:cNvPr id="14" name=""/>
+          <p:cNvPicPr>
+            <a:picLocks xmlns:a="http://schemas.openxmlformats.org/drawingml/2006/main" noChangeAspect="1"/>
+          </p:cNvPicPr>
+          <p:nvPr/>
+        </p:nvPicPr>
+        <p:blipFill>
+          <a:blip xmlns:r="http://schemas.openxmlformats.org/officeDocument/2006/relationships" xmlns:a="http://schemas.openxmlformats.org/drawingml/2006/main" r:embed="R32ddcc38557e49d4"/>
+          <a:stretch xmlns:a="http://schemas.openxmlformats.org/drawingml/2006/main"/>
+        </p:blipFill>
+        <p:spPr>
+          <a:xfrm xmlns:a="http://schemas.openxmlformats.org/drawingml/2006/main">
+            <a:off x="1462686" y="1258058"/>
+            <a:ext cx="9266627" cy="5103884"/>
+          </a:xfrm>
+          <a:prstGeom xmlns:a="http://schemas.openxmlformats.org/drawingml/2006/main" prst="rect">
+            <a:avLst/>
+          </a:prstGeom>
+        </p:spPr>
+      </p:pic>
     </p:spTree>
     <p:extLst>
       <p:ext uri="{BB962C8B-B14F-4D97-AF65-F5344CB8AC3E}">
-        <p14:creationId xmlns:p14="http://schemas.microsoft.com/office/powerpoint/2010/main" val="2028502474"/>
+        <p14:creationId xmlns:p14="http://schemas.microsoft.com/office/powerpoint/2010/main" val="248175514"/>
       </p:ext>
     </p:extLst>
   </p:cSld>
@@ -7364,7 +6336,7 @@
           <p:nvPr/>
         </p:nvPicPr>
         <p:blipFill>
-          <a:blip xmlns:r="http://schemas.openxmlformats.org/officeDocument/2006/relationships" xmlns:a="http://schemas.openxmlformats.org/drawingml/2006/main" r:embed="Ra09c94facd8c44eb"/>
+          <a:blip xmlns:r="http://schemas.openxmlformats.org/officeDocument/2006/relationships" xmlns:a="http://schemas.openxmlformats.org/drawingml/2006/main" r:embed="R07aade6b7b8e4049"/>
           <a:stretch xmlns:a="http://schemas.openxmlformats.org/drawingml/2006/main"/>
         </p:blipFill>
         <p:spPr>
@@ -7448,7 +6420,7 @@
           <p:nvPr/>
         </p:nvPicPr>
         <p:blipFill>
-          <a:blip xmlns:r="http://schemas.openxmlformats.org/officeDocument/2006/relationships" xmlns:a="http://schemas.openxmlformats.org/drawingml/2006/main" r:embed="R4dd583d997f04e1a"/>
+          <a:blip xmlns:r="http://schemas.openxmlformats.org/officeDocument/2006/relationships" xmlns:a="http://schemas.openxmlformats.org/drawingml/2006/main" r:embed="R39bf30468acb403f"/>
           <a:srcRect xmlns:a="http://schemas.openxmlformats.org/drawingml/2006/main" l="0" t="0" r="0" b="0"/>
           <a:stretch xmlns:a="http://schemas.openxmlformats.org/drawingml/2006/main"/>
         </p:blipFill>

</xml_diff>